<commit_message>
Update final presentation: team names, slide fixes, add routing diagram
- Add team member names with roll numbers to slide 1
- Fix slide 3 tile borders and accent bars for cross-app rendering
- Fix slide 15 RAGAS summary text overlap with metric panel
- Add re-routing system architecture diagram (drawio export)
- Update Milestone 6 slides

Co-Authored-By: Claude Sonnet 4.6 <noreply@anthropic.com>
</commit_message>
<xml_diff>
--- a/Slides/DSAI_Team_6_Milestone6.pptx
+++ b/Slides/DSAI_Team_6_Milestone6.pptx
@@ -80,7 +80,7 @@
         <p:txBody>
           <a:bodyPr/>
           <a:p>
-            <a:fld id="{462DEF47-B825-4AF8-A1D9-3FABC6BD36C0}" type="slidenum">
+            <a:fld id="{B9109B0A-A9EC-44EC-A9EC-E3A5D4880797}" type="slidenum">
               <a:t>&lt;#&gt;</a:t>
             </a:fld>
           </a:p>
@@ -274,7 +274,7 @@
         <p:txBody>
           <a:bodyPr/>
           <a:p>
-            <a:fld id="{62F17FA0-BA96-49D1-BF59-A58DBF51E4CA}" type="slidenum">
+            <a:fld id="{014941A0-75DB-4A60-8003-D573A34AE4E4}" type="slidenum">
               <a:t>&lt;#&gt;</a:t>
             </a:fld>
           </a:p>
@@ -542,7 +542,7 @@
         <p:txBody>
           <a:bodyPr/>
           <a:p>
-            <a:fld id="{295C6D16-6376-4D0D-865A-6DA0FA00D85E}" type="slidenum">
+            <a:fld id="{39EDBC0B-A4F5-4D87-BF03-42BD83FCD279}" type="slidenum">
               <a:t>&lt;#&gt;</a:t>
             </a:fld>
           </a:p>
@@ -884,7 +884,7 @@
         <p:txBody>
           <a:bodyPr/>
           <a:p>
-            <a:fld id="{71A06E58-EBD2-49E7-A6C9-002F5EA1F195}" type="slidenum">
+            <a:fld id="{CAB58437-7A55-4BE8-817D-B4C38068DCED}" type="slidenum">
               <a:t>&lt;#&gt;</a:t>
             </a:fld>
           </a:p>
@@ -1041,7 +1041,7 @@
         <p:txBody>
           <a:bodyPr/>
           <a:p>
-            <a:fld id="{92244925-5BDE-4E48-BE04-4CD3E0191950}" type="slidenum">
+            <a:fld id="{BF590BFD-C2BE-442B-A853-87E004CF29AA}" type="slidenum">
               <a:t>&lt;#&gt;</a:t>
             </a:fld>
           </a:p>
@@ -1198,7 +1198,7 @@
         <p:txBody>
           <a:bodyPr/>
           <a:p>
-            <a:fld id="{8B35E11C-10BE-49E9-B182-B4385DA8A99C}" type="slidenum">
+            <a:fld id="{1649CB48-B927-4A69-BB71-94F8912B85E3}" type="slidenum">
               <a:t>&lt;#&gt;</a:t>
             </a:fld>
           </a:p>
@@ -1392,7 +1392,7 @@
         <p:txBody>
           <a:bodyPr/>
           <a:p>
-            <a:fld id="{CA6C9004-5235-469A-A754-4A3AD463BA87}" type="slidenum">
+            <a:fld id="{C4E5FD35-970E-409E-9071-8B24E6BCA224}" type="slidenum">
               <a:t>&lt;#&gt;</a:t>
             </a:fld>
           </a:p>
@@ -1512,7 +1512,7 @@
         <p:txBody>
           <a:bodyPr/>
           <a:p>
-            <a:fld id="{F81F452D-16BA-40B0-A56B-D92A38309EDD}" type="slidenum">
+            <a:fld id="{5D0137A8-141C-460F-8824-5310DE9A6000}" type="slidenum">
               <a:t>&lt;#&gt;</a:t>
             </a:fld>
           </a:p>
@@ -1632,7 +1632,7 @@
         <p:txBody>
           <a:bodyPr/>
           <a:p>
-            <a:fld id="{77944719-9685-4745-A32B-1E6FB47939F6}" type="slidenum">
+            <a:fld id="{50F45665-71F1-4C23-B518-028664410946}" type="slidenum">
               <a:t>&lt;#&gt;</a:t>
             </a:fld>
           </a:p>
@@ -1863,7 +1863,7 @@
         <p:txBody>
           <a:bodyPr/>
           <a:p>
-            <a:fld id="{CD456079-D7A6-4C0E-8A91-9F060D0A840E}" type="slidenum">
+            <a:fld id="{71C6DFBE-2A3E-42D6-A87A-15CBFD386479}" type="slidenum">
               <a:t>&lt;#&gt;</a:t>
             </a:fld>
           </a:p>
@@ -2094,7 +2094,7 @@
         <p:txBody>
           <a:bodyPr/>
           <a:p>
-            <a:fld id="{66205DB8-2BB5-42F5-8D66-0CE03700383A}" type="slidenum">
+            <a:fld id="{AAC2CCB3-1C0A-4041-91AC-6CE3AB04FC82}" type="slidenum">
               <a:t>&lt;#&gt;</a:t>
             </a:fld>
           </a:p>
@@ -2325,7 +2325,7 @@
         <p:txBody>
           <a:bodyPr/>
           <a:p>
-            <a:fld id="{C04D9564-40EA-4C6E-9251-916F1477986F}" type="slidenum">
+            <a:fld id="{C23C1515-E911-4916-AA4E-7AB2F7F23150}" type="slidenum">
               <a:t>&lt;#&gt;</a:t>
             </a:fld>
           </a:p>
@@ -2543,7 +2543,7 @@
               </a:lnSpc>
               <a:buNone/>
             </a:pPr>
-            <a:fld id="{C41B7331-9402-4591-9BFD-110E41EFF412}" type="slidenum">
+            <a:fld id="{2DFE43B2-AF31-43B8-8F98-8E50CF8E69CF}" type="slidenum">
               <a:rPr b="0" lang="en-US" sz="1200" spc="-1" strike="noStrike">
                 <a:solidFill>
                   <a:srgbClr val="8b8b8b"/>
@@ -2898,7 +2898,7 @@
                 <a:latin typeface="Calibri"/>
                 <a:ea typeface="Calibri"/>
               </a:rPr>
-              <a:t>An AI-</a:t>
+              <a:t>An AI-Powered, </a:t>
             </a:r>
             <a:r>
               <a:rPr b="0" i="1" lang="en-US" sz="1800" spc="-1" strike="noStrike">
@@ -2908,7 +2908,7 @@
                 <a:latin typeface="Calibri"/>
                 <a:ea typeface="Calibri"/>
               </a:rPr>
-              <a:t>Power</a:t>
+              <a:t>Stock-Specific </a:t>
             </a:r>
             <a:r>
               <a:rPr b="0" i="1" lang="en-US" sz="1800" spc="-1" strike="noStrike">
@@ -2918,7 +2918,7 @@
                 <a:latin typeface="Calibri"/>
                 <a:ea typeface="Calibri"/>
               </a:rPr>
-              <a:t>ed, </a:t>
+              <a:t>Public Update </a:t>
             </a:r>
             <a:r>
               <a:rPr b="0" i="1" lang="en-US" sz="1800" spc="-1" strike="noStrike">
@@ -2928,8 +2928,13 @@
                 <a:latin typeface="Calibri"/>
                 <a:ea typeface="Calibri"/>
               </a:rPr>
-              <a:t>Stock-</a:t>
-            </a:r>
+              <a:t>Analyzer</a:t>
+            </a:r>
+            <a:endParaRPr b="0" lang="en-US" sz="1800" spc="-1" strike="noStrike">
+              <a:latin typeface="Arial"/>
+            </a:endParaRPr>
+          </a:p>
+          <a:p>
             <a:r>
               <a:rPr b="0" i="1" lang="en-US" sz="1800" spc="-1" strike="noStrike">
                 <a:solidFill>
@@ -2938,7 +2943,7 @@
                 <a:latin typeface="Calibri"/>
                 <a:ea typeface="Calibri"/>
               </a:rPr>
-              <a:t>Speci</a:t>
+              <a:t>for Indian </a:t>
             </a:r>
             <a:r>
               <a:rPr b="0" i="1" lang="en-US" sz="1800" spc="-1" strike="noStrike">
@@ -2948,122 +2953,7 @@
                 <a:latin typeface="Calibri"/>
                 <a:ea typeface="Calibri"/>
               </a:rPr>
-              <a:t>fic </a:t>
-            </a:r>
-            <a:r>
-              <a:rPr b="0" i="1" lang="en-US" sz="1800" spc="-1" strike="noStrike">
-                <a:solidFill>
-                  <a:srgbClr val="cadcfc"/>
-                </a:solidFill>
-                <a:latin typeface="Calibri"/>
-                <a:ea typeface="Calibri"/>
-              </a:rPr>
-              <a:t>Public </a:t>
-            </a:r>
-            <a:r>
-              <a:rPr b="0" i="1" lang="en-US" sz="1800" spc="-1" strike="noStrike">
-                <a:solidFill>
-                  <a:srgbClr val="cadcfc"/>
-                </a:solidFill>
-                <a:latin typeface="Calibri"/>
-                <a:ea typeface="Calibri"/>
-              </a:rPr>
-              <a:t>Updat</a:t>
-            </a:r>
-            <a:r>
-              <a:rPr b="0" i="1" lang="en-US" sz="1800" spc="-1" strike="noStrike">
-                <a:solidFill>
-                  <a:srgbClr val="cadcfc"/>
-                </a:solidFill>
-                <a:latin typeface="Calibri"/>
-                <a:ea typeface="Calibri"/>
-              </a:rPr>
-              <a:t>e </a:t>
-            </a:r>
-            <a:r>
-              <a:rPr b="0" i="1" lang="en-US" sz="1800" spc="-1" strike="noStrike">
-                <a:solidFill>
-                  <a:srgbClr val="cadcfc"/>
-                </a:solidFill>
-                <a:latin typeface="Calibri"/>
-                <a:ea typeface="Calibri"/>
-              </a:rPr>
-              <a:t>Analy</a:t>
-            </a:r>
-            <a:r>
-              <a:rPr b="0" i="1" lang="en-US" sz="1800" spc="-1" strike="noStrike">
-                <a:solidFill>
-                  <a:srgbClr val="cadcfc"/>
-                </a:solidFill>
-                <a:latin typeface="Calibri"/>
-                <a:ea typeface="Calibri"/>
-              </a:rPr>
-              <a:t>zer</a:t>
-            </a:r>
-            <a:endParaRPr b="0" lang="en-US" sz="1800" spc="-1" strike="noStrike">
-              <a:latin typeface="Arial"/>
-            </a:endParaRPr>
-          </a:p>
-          <a:p>
-            <a:r>
-              <a:rPr b="0" i="1" lang="en-US" sz="1800" spc="-1" strike="noStrike">
-                <a:solidFill>
-                  <a:srgbClr val="cadcfc"/>
-                </a:solidFill>
-                <a:latin typeface="Calibri"/>
-                <a:ea typeface="Calibri"/>
-              </a:rPr>
-              <a:t>for </a:t>
-            </a:r>
-            <a:r>
-              <a:rPr b="0" i="1" lang="en-US" sz="1800" spc="-1" strike="noStrike">
-                <a:solidFill>
-                  <a:srgbClr val="cadcfc"/>
-                </a:solidFill>
-                <a:latin typeface="Calibri"/>
-                <a:ea typeface="Calibri"/>
-              </a:rPr>
-              <a:t>Indian </a:t>
-            </a:r>
-            <a:r>
-              <a:rPr b="0" i="1" lang="en-US" sz="1800" spc="-1" strike="noStrike">
-                <a:solidFill>
-                  <a:srgbClr val="cadcfc"/>
-                </a:solidFill>
-                <a:latin typeface="Calibri"/>
-                <a:ea typeface="Calibri"/>
-              </a:rPr>
-              <a:t>Capita</a:t>
-            </a:r>
-            <a:r>
-              <a:rPr b="0" i="1" lang="en-US" sz="1800" spc="-1" strike="noStrike">
-                <a:solidFill>
-                  <a:srgbClr val="cadcfc"/>
-                </a:solidFill>
-                <a:latin typeface="Calibri"/>
-                <a:ea typeface="Calibri"/>
-              </a:rPr>
-              <a:t>l </a:t>
-            </a:r>
-            <a:r>
-              <a:rPr b="0" i="1" lang="en-US" sz="1800" spc="-1" strike="noStrike">
-                <a:solidFill>
-                  <a:srgbClr val="cadcfc"/>
-                </a:solidFill>
-                <a:latin typeface="Calibri"/>
-                <a:ea typeface="Calibri"/>
-              </a:rPr>
-              <a:t>Marke</a:t>
-            </a:r>
-            <a:r>
-              <a:rPr b="0" i="1" lang="en-US" sz="1800" spc="-1" strike="noStrike">
-                <a:solidFill>
-                  <a:srgbClr val="cadcfc"/>
-                </a:solidFill>
-                <a:latin typeface="Calibri"/>
-                <a:ea typeface="Calibri"/>
-              </a:rPr>
-              <a:t>ts</a:t>
+              <a:t>Capital Markets</a:t>
             </a:r>
             <a:endParaRPr b="0" lang="en-US" sz="1800" spc="-1" strike="noStrike">
               <a:latin typeface="Arial"/>
@@ -3536,7 +3426,57 @@
                 <a:latin typeface="Calibri"/>
                 <a:ea typeface="Calibri"/>
               </a:rPr>
-              <a:t>An AI-Powered, Stock-Specific Public Update Analyzer for Indian Capital Markets</a:t>
+              <a:t>An AI-Powered, </a:t>
+            </a:r>
+            <a:r>
+              <a:rPr b="0" i="1" lang="en-US" sz="1800" spc="-1" strike="noStrike">
+                <a:solidFill>
+                  <a:srgbClr val="cadcfc"/>
+                </a:solidFill>
+                <a:latin typeface="Calibri"/>
+                <a:ea typeface="Calibri"/>
+              </a:rPr>
+              <a:t>Stock-Specific </a:t>
+            </a:r>
+            <a:r>
+              <a:rPr b="0" i="1" lang="en-US" sz="1800" spc="-1" strike="noStrike">
+                <a:solidFill>
+                  <a:srgbClr val="cadcfc"/>
+                </a:solidFill>
+                <a:latin typeface="Calibri"/>
+                <a:ea typeface="Calibri"/>
+              </a:rPr>
+              <a:t>Public Update </a:t>
+            </a:r>
+            <a:r>
+              <a:rPr b="0" i="1" lang="en-US" sz="1800" spc="-1" strike="noStrike">
+                <a:solidFill>
+                  <a:srgbClr val="cadcfc"/>
+                </a:solidFill>
+                <a:latin typeface="Calibri"/>
+                <a:ea typeface="Calibri"/>
+              </a:rPr>
+              <a:t>Analyzer for </a:t>
+            </a:r>
+            <a:r>
+              <a:rPr b="0" i="1" lang="en-US" sz="1800" spc="-1" strike="noStrike">
+                <a:solidFill>
+                  <a:srgbClr val="cadcfc"/>
+                </a:solidFill>
+                <a:latin typeface="Calibri"/>
+                <a:ea typeface="Calibri"/>
+              </a:rPr>
+              <a:t>Indian Capital </a:t>
+            </a:r>
+            <a:r>
+              <a:rPr b="0" i="1" lang="en-US" sz="1800" spc="-1" strike="noStrike">
+                <a:solidFill>
+                  <a:srgbClr val="cadcfc"/>
+                </a:solidFill>
+                <a:latin typeface="Calibri"/>
+                <a:ea typeface="Calibri"/>
+              </a:rPr>
+              <a:t>Markets</a:t>
             </a:r>
             <a:endParaRPr b="0" lang="en-US" sz="1800" spc="-1" strike="noStrike">
               <a:latin typeface="Arial"/>
@@ -3727,7 +3667,7 @@
       </p:grpSpPr>
       <p:sp>
         <p:nvSpPr>
-          <p:cNvPr id="193" name="Rectangle 1"/>
+          <p:cNvPr id="192" name="Rectangle 1"/>
           <p:cNvSpPr/>
           <p:nvPr/>
         </p:nvSpPr>
@@ -3768,7 +3708,7 @@
       </p:sp>
       <p:sp>
         <p:nvSpPr>
-          <p:cNvPr id="194" name="TextBox 2"/>
+          <p:cNvPr id="193" name="TextBox 2"/>
           <p:cNvSpPr/>
           <p:nvPr/>
         </p:nvSpPr>
@@ -3819,7 +3759,7 @@
       </p:sp>
       <p:sp>
         <p:nvSpPr>
-          <p:cNvPr id="195" name="TextBox 3"/>
+          <p:cNvPr id="194" name="TextBox 3"/>
           <p:cNvSpPr/>
           <p:nvPr/>
         </p:nvSpPr>
@@ -3870,7 +3810,7 @@
       </p:sp>
       <p:sp>
         <p:nvSpPr>
-          <p:cNvPr id="196" name="TextBox 4"/>
+          <p:cNvPr id="195" name="TextBox 4"/>
           <p:cNvSpPr/>
           <p:nvPr/>
         </p:nvSpPr>
@@ -3921,7 +3861,7 @@
       </p:sp>
       <p:sp>
         <p:nvSpPr>
-          <p:cNvPr id="197" name="Rectangle 5"/>
+          <p:cNvPr id="196" name="Rectangle 5"/>
           <p:cNvSpPr/>
           <p:nvPr/>
         </p:nvSpPr>
@@ -3965,7 +3905,7 @@
       </p:sp>
       <p:sp>
         <p:nvSpPr>
-          <p:cNvPr id="198" name="TextBox 6"/>
+          <p:cNvPr id="197" name="TextBox 6"/>
           <p:cNvSpPr/>
           <p:nvPr/>
         </p:nvSpPr>
@@ -4025,7 +3965,7 @@
       </p:sp>
       <p:sp>
         <p:nvSpPr>
-          <p:cNvPr id="199" name="TextBox 7"/>
+          <p:cNvPr id="198" name="TextBox 7"/>
           <p:cNvSpPr/>
           <p:nvPr/>
         </p:nvSpPr>
@@ -4076,7 +4016,7 @@
       </p:sp>
       <p:sp>
         <p:nvSpPr>
-          <p:cNvPr id="200" name="Rectangle 8"/>
+          <p:cNvPr id="199" name="Rectangle 8"/>
           <p:cNvSpPr/>
           <p:nvPr/>
         </p:nvSpPr>
@@ -4120,7 +4060,7 @@
       </p:sp>
       <p:sp>
         <p:nvSpPr>
-          <p:cNvPr id="201" name="TextBox 9"/>
+          <p:cNvPr id="200" name="TextBox 9"/>
           <p:cNvSpPr/>
           <p:nvPr/>
         </p:nvSpPr>
@@ -4180,7 +4120,7 @@
       </p:sp>
       <p:sp>
         <p:nvSpPr>
-          <p:cNvPr id="202" name="TextBox 10"/>
+          <p:cNvPr id="201" name="TextBox 10"/>
           <p:cNvSpPr/>
           <p:nvPr/>
         </p:nvSpPr>
@@ -4231,7 +4171,7 @@
       </p:sp>
       <p:sp>
         <p:nvSpPr>
-          <p:cNvPr id="203" name="Rectangle 11"/>
+          <p:cNvPr id="202" name="Rectangle 11"/>
           <p:cNvSpPr/>
           <p:nvPr/>
         </p:nvSpPr>
@@ -4275,7 +4215,7 @@
       </p:sp>
       <p:sp>
         <p:nvSpPr>
-          <p:cNvPr id="204" name="TextBox 12"/>
+          <p:cNvPr id="203" name="TextBox 12"/>
           <p:cNvSpPr/>
           <p:nvPr/>
         </p:nvSpPr>
@@ -4335,7 +4275,7 @@
       </p:sp>
       <p:sp>
         <p:nvSpPr>
-          <p:cNvPr id="205" name="TextBox 13"/>
+          <p:cNvPr id="204" name="TextBox 13"/>
           <p:cNvSpPr/>
           <p:nvPr/>
         </p:nvSpPr>
@@ -4386,7 +4326,7 @@
       </p:sp>
       <p:sp>
         <p:nvSpPr>
-          <p:cNvPr id="206" name="Rectangle 14"/>
+          <p:cNvPr id="205" name="Rectangle 14"/>
           <p:cNvSpPr/>
           <p:nvPr/>
         </p:nvSpPr>
@@ -4430,7 +4370,7 @@
       </p:sp>
       <p:sp>
         <p:nvSpPr>
-          <p:cNvPr id="207" name="TextBox 15"/>
+          <p:cNvPr id="206" name="TextBox 15"/>
           <p:cNvSpPr/>
           <p:nvPr/>
         </p:nvSpPr>
@@ -4490,7 +4430,7 @@
       </p:sp>
       <p:sp>
         <p:nvSpPr>
-          <p:cNvPr id="208" name="TextBox 16"/>
+          <p:cNvPr id="207" name="TextBox 16"/>
           <p:cNvSpPr/>
           <p:nvPr/>
         </p:nvSpPr>
@@ -4541,7 +4481,7 @@
       </p:sp>
       <p:sp>
         <p:nvSpPr>
-          <p:cNvPr id="209" name="Rectangle 17"/>
+          <p:cNvPr id="208" name="Rectangle 17"/>
           <p:cNvSpPr/>
           <p:nvPr/>
         </p:nvSpPr>
@@ -4585,7 +4525,7 @@
       </p:sp>
       <p:sp>
         <p:nvSpPr>
-          <p:cNvPr id="210" name="TextBox 18"/>
+          <p:cNvPr id="209" name="TextBox 18"/>
           <p:cNvSpPr/>
           <p:nvPr/>
         </p:nvSpPr>
@@ -4645,7 +4585,7 @@
       </p:sp>
       <p:sp>
         <p:nvSpPr>
-          <p:cNvPr id="211" name="TextBox 19"/>
+          <p:cNvPr id="210" name="TextBox 19"/>
           <p:cNvSpPr/>
           <p:nvPr/>
         </p:nvSpPr>
@@ -4726,7 +4666,7 @@
       </p:grpSpPr>
       <p:sp>
         <p:nvSpPr>
-          <p:cNvPr id="212" name="Rectangle 1"/>
+          <p:cNvPr id="211" name="Rectangle 1"/>
           <p:cNvSpPr/>
           <p:nvPr/>
         </p:nvSpPr>
@@ -4767,7 +4707,7 @@
       </p:sp>
       <p:sp>
         <p:nvSpPr>
-          <p:cNvPr id="213" name="TextBox 2"/>
+          <p:cNvPr id="212" name="TextBox 2"/>
           <p:cNvSpPr/>
           <p:nvPr/>
         </p:nvSpPr>
@@ -4818,7 +4758,7 @@
       </p:sp>
       <p:sp>
         <p:nvSpPr>
-          <p:cNvPr id="214" name="TextBox 3"/>
+          <p:cNvPr id="213" name="TextBox 3"/>
           <p:cNvSpPr/>
           <p:nvPr/>
         </p:nvSpPr>
@@ -4869,7 +4809,7 @@
       </p:sp>
       <p:sp>
         <p:nvSpPr>
-          <p:cNvPr id="215" name="TextBox 4"/>
+          <p:cNvPr id="214" name="TextBox 4"/>
           <p:cNvSpPr/>
           <p:nvPr/>
         </p:nvSpPr>
@@ -4920,7 +4860,7 @@
       </p:sp>
       <p:sp>
         <p:nvSpPr>
-          <p:cNvPr id="216" name="Rectangle 5"/>
+          <p:cNvPr id="215" name="Rectangle 5"/>
           <p:cNvSpPr/>
           <p:nvPr/>
         </p:nvSpPr>
@@ -4964,7 +4904,7 @@
       </p:sp>
       <p:sp>
         <p:nvSpPr>
-          <p:cNvPr id="217" name="TextBox 6"/>
+          <p:cNvPr id="216" name="TextBox 6"/>
           <p:cNvSpPr/>
           <p:nvPr/>
         </p:nvSpPr>
@@ -5015,7 +4955,7 @@
       </p:sp>
       <p:sp>
         <p:nvSpPr>
-          <p:cNvPr id="218" name="TextBox 7"/>
+          <p:cNvPr id="217" name="TextBox 7"/>
           <p:cNvSpPr/>
           <p:nvPr/>
         </p:nvSpPr>
@@ -5089,7 +5029,7 @@
       </p:sp>
       <p:sp>
         <p:nvSpPr>
-          <p:cNvPr id="219" name="TextBox 8"/>
+          <p:cNvPr id="218" name="TextBox 8"/>
           <p:cNvSpPr/>
           <p:nvPr/>
         </p:nvSpPr>
@@ -5140,7 +5080,7 @@
       </p:sp>
       <p:sp>
         <p:nvSpPr>
-          <p:cNvPr id="220" name="Rectangle 9"/>
+          <p:cNvPr id="219" name="Rectangle 9"/>
           <p:cNvSpPr/>
           <p:nvPr/>
         </p:nvSpPr>
@@ -5184,7 +5124,7 @@
       </p:sp>
       <p:sp>
         <p:nvSpPr>
-          <p:cNvPr id="221" name="TextBox 10"/>
+          <p:cNvPr id="220" name="TextBox 10"/>
           <p:cNvSpPr/>
           <p:nvPr/>
         </p:nvSpPr>
@@ -5235,7 +5175,7 @@
       </p:sp>
       <p:sp>
         <p:nvSpPr>
-          <p:cNvPr id="222" name="TextBox 11"/>
+          <p:cNvPr id="221" name="TextBox 11"/>
           <p:cNvSpPr/>
           <p:nvPr/>
         </p:nvSpPr>
@@ -5378,7 +5318,7 @@
       </p:sp>
       <p:sp>
         <p:nvSpPr>
-          <p:cNvPr id="223" name="Rectangle 12"/>
+          <p:cNvPr id="222" name="Rectangle 12"/>
           <p:cNvSpPr/>
           <p:nvPr/>
         </p:nvSpPr>
@@ -5422,7 +5362,7 @@
       </p:sp>
       <p:sp>
         <p:nvSpPr>
-          <p:cNvPr id="224" name="TextBox 13"/>
+          <p:cNvPr id="223" name="TextBox 13"/>
           <p:cNvSpPr/>
           <p:nvPr/>
         </p:nvSpPr>
@@ -5473,7 +5413,7 @@
       </p:sp>
       <p:sp>
         <p:nvSpPr>
-          <p:cNvPr id="225" name="TextBox 14"/>
+          <p:cNvPr id="224" name="TextBox 14"/>
           <p:cNvSpPr/>
           <p:nvPr/>
         </p:nvSpPr>
@@ -5646,7 +5586,7 @@
       </p:grpSpPr>
       <p:sp>
         <p:nvSpPr>
-          <p:cNvPr id="226" name="Rectangle 1"/>
+          <p:cNvPr id="225" name="Rectangle 1"/>
           <p:cNvSpPr/>
           <p:nvPr/>
         </p:nvSpPr>
@@ -5687,7 +5627,7 @@
       </p:sp>
       <p:sp>
         <p:nvSpPr>
-          <p:cNvPr id="227" name="TextBox 2"/>
+          <p:cNvPr id="226" name="TextBox 2"/>
           <p:cNvSpPr/>
           <p:nvPr/>
         </p:nvSpPr>
@@ -5738,7 +5678,7 @@
       </p:sp>
       <p:sp>
         <p:nvSpPr>
-          <p:cNvPr id="228" name="TextBox 3"/>
+          <p:cNvPr id="227" name="TextBox 3"/>
           <p:cNvSpPr/>
           <p:nvPr/>
         </p:nvSpPr>
@@ -5789,7 +5729,7 @@
       </p:sp>
       <p:sp>
         <p:nvSpPr>
-          <p:cNvPr id="229" name="TextBox 4"/>
+          <p:cNvPr id="228" name="TextBox 4"/>
           <p:cNvSpPr/>
           <p:nvPr/>
         </p:nvSpPr>
@@ -5840,7 +5780,7 @@
       </p:sp>
       <p:pic>
         <p:nvPicPr>
-          <p:cNvPr id="230" name="Picture 5" descr="m6_quality_v2.png"/>
+          <p:cNvPr id="229" name="Picture 5" descr="m6_quality_v2.png"/>
           <p:cNvPicPr/>
           <p:nvPr/>
         </p:nvPicPr>
@@ -5863,7 +5803,7 @@
       </p:pic>
       <p:sp>
         <p:nvSpPr>
-          <p:cNvPr id="231" name="Rectangle 6"/>
+          <p:cNvPr id="230" name="Rectangle 6"/>
           <p:cNvSpPr/>
           <p:nvPr/>
         </p:nvSpPr>
@@ -5907,7 +5847,7 @@
       </p:sp>
       <p:sp>
         <p:nvSpPr>
-          <p:cNvPr id="232" name="TextBox 7"/>
+          <p:cNvPr id="231" name="TextBox 7"/>
           <p:cNvSpPr/>
           <p:nvPr/>
         </p:nvSpPr>
@@ -5958,7 +5898,7 @@
       </p:sp>
       <p:sp>
         <p:nvSpPr>
-          <p:cNvPr id="233" name="TextBox 8"/>
+          <p:cNvPr id="232" name="TextBox 8"/>
           <p:cNvSpPr/>
           <p:nvPr/>
         </p:nvSpPr>
@@ -6009,7 +5949,7 @@
       </p:sp>
       <p:sp>
         <p:nvSpPr>
-          <p:cNvPr id="234" name="TextBox 9"/>
+          <p:cNvPr id="233" name="TextBox 9"/>
           <p:cNvSpPr/>
           <p:nvPr/>
         </p:nvSpPr>
@@ -6102,7 +6042,7 @@
       </p:sp>
       <p:sp>
         <p:nvSpPr>
-          <p:cNvPr id="235" name="TextBox 10"/>
+          <p:cNvPr id="234" name="TextBox 10"/>
           <p:cNvSpPr/>
           <p:nvPr/>
         </p:nvSpPr>
@@ -6153,7 +6093,7 @@
       </p:sp>
       <p:sp>
         <p:nvSpPr>
-          <p:cNvPr id="236" name="TextBox 11"/>
+          <p:cNvPr id="235" name="TextBox 11"/>
           <p:cNvSpPr/>
           <p:nvPr/>
         </p:nvSpPr>
@@ -6232,7 +6172,7 @@
       </p:sp>
       <p:sp>
         <p:nvSpPr>
-          <p:cNvPr id="237" name="TextBox 12"/>
+          <p:cNvPr id="236" name="TextBox 12"/>
           <p:cNvSpPr/>
           <p:nvPr/>
         </p:nvSpPr>
@@ -6283,7 +6223,7 @@
       </p:sp>
       <p:sp>
         <p:nvSpPr>
-          <p:cNvPr id="238" name="TextBox 13"/>
+          <p:cNvPr id="237" name="TextBox 13"/>
           <p:cNvSpPr/>
           <p:nvPr/>
         </p:nvSpPr>
@@ -6362,7 +6302,7 @@
       </p:sp>
       <p:sp>
         <p:nvSpPr>
-          <p:cNvPr id="239" name="Rectangle 14"/>
+          <p:cNvPr id="238" name="Rectangle 14"/>
           <p:cNvSpPr/>
           <p:nvPr/>
         </p:nvSpPr>
@@ -6406,7 +6346,7 @@
       </p:sp>
       <p:sp>
         <p:nvSpPr>
-          <p:cNvPr id="240" name="TextBox 15"/>
+          <p:cNvPr id="239" name="TextBox 15"/>
           <p:cNvSpPr/>
           <p:nvPr/>
         </p:nvSpPr>
@@ -6457,7 +6397,7 @@
       </p:sp>
       <p:sp>
         <p:nvSpPr>
-          <p:cNvPr id="241" name="TextBox 16"/>
+          <p:cNvPr id="240" name="TextBox 16"/>
           <p:cNvSpPr/>
           <p:nvPr/>
         </p:nvSpPr>
@@ -6538,7 +6478,7 @@
       </p:grpSpPr>
       <p:sp>
         <p:nvSpPr>
-          <p:cNvPr id="242" name="Rectangle 1"/>
+          <p:cNvPr id="241" name="Rectangle 1"/>
           <p:cNvSpPr/>
           <p:nvPr/>
         </p:nvSpPr>
@@ -6579,7 +6519,7 @@
       </p:sp>
       <p:sp>
         <p:nvSpPr>
-          <p:cNvPr id="243" name="TextBox 2"/>
+          <p:cNvPr id="242" name="TextBox 2"/>
           <p:cNvSpPr/>
           <p:nvPr/>
         </p:nvSpPr>
@@ -6630,7 +6570,7 @@
       </p:sp>
       <p:sp>
         <p:nvSpPr>
-          <p:cNvPr id="244" name="TextBox 3"/>
+          <p:cNvPr id="243" name="TextBox 3"/>
           <p:cNvSpPr/>
           <p:nvPr/>
         </p:nvSpPr>
@@ -6681,7 +6621,7 @@
       </p:sp>
       <p:sp>
         <p:nvSpPr>
-          <p:cNvPr id="245" name="TextBox 4"/>
+          <p:cNvPr id="244" name="TextBox 4"/>
           <p:cNvSpPr/>
           <p:nvPr/>
         </p:nvSpPr>
@@ -6732,7 +6672,7 @@
       </p:sp>
       <p:pic>
         <p:nvPicPr>
-          <p:cNvPr id="246" name="Picture 5" descr="m6_architecture.png"/>
+          <p:cNvPr id="245" name="Picture 5" descr="m6_architecture.png"/>
           <p:cNvPicPr/>
           <p:nvPr/>
         </p:nvPicPr>
@@ -6755,7 +6695,7 @@
       </p:pic>
       <p:sp>
         <p:nvSpPr>
-          <p:cNvPr id="247" name="Rectangle 6"/>
+          <p:cNvPr id="246" name="Rectangle 6"/>
           <p:cNvSpPr/>
           <p:nvPr/>
         </p:nvSpPr>
@@ -6799,7 +6739,7 @@
       </p:sp>
       <p:sp>
         <p:nvSpPr>
-          <p:cNvPr id="248" name="TextBox 7"/>
+          <p:cNvPr id="247" name="TextBox 7"/>
           <p:cNvSpPr/>
           <p:nvPr/>
         </p:nvSpPr>
@@ -6850,7 +6790,7 @@
       </p:sp>
       <p:sp>
         <p:nvSpPr>
-          <p:cNvPr id="249" name="TextBox 8"/>
+          <p:cNvPr id="248" name="TextBox 8"/>
           <p:cNvSpPr/>
           <p:nvPr/>
         </p:nvSpPr>
@@ -7013,7 +6953,7 @@
       </p:sp>
       <p:sp>
         <p:nvSpPr>
-          <p:cNvPr id="250" name="Rectangle 9"/>
+          <p:cNvPr id="249" name="Rectangle 9"/>
           <p:cNvSpPr/>
           <p:nvPr/>
         </p:nvSpPr>
@@ -7057,7 +6997,7 @@
       </p:sp>
       <p:sp>
         <p:nvSpPr>
-          <p:cNvPr id="251" name="TextBox 10"/>
+          <p:cNvPr id="250" name="TextBox 10"/>
           <p:cNvSpPr/>
           <p:nvPr/>
         </p:nvSpPr>
@@ -7108,7 +7048,7 @@
       </p:sp>
       <p:sp>
         <p:nvSpPr>
-          <p:cNvPr id="252" name="TextBox 11"/>
+          <p:cNvPr id="251" name="TextBox 11"/>
           <p:cNvSpPr/>
           <p:nvPr/>
         </p:nvSpPr>
@@ -7283,7 +7223,7 @@
       </p:sp>
       <p:sp>
         <p:nvSpPr>
-          <p:cNvPr id="253" name="TextBox 12"/>
+          <p:cNvPr id="252" name="TextBox 12"/>
           <p:cNvSpPr/>
           <p:nvPr/>
         </p:nvSpPr>
@@ -7378,7 +7318,7 @@
       </p:grpSpPr>
       <p:sp>
         <p:nvSpPr>
-          <p:cNvPr id="254" name="Rectangle 1"/>
+          <p:cNvPr id="253" name="Rectangle 1"/>
           <p:cNvSpPr/>
           <p:nvPr/>
         </p:nvSpPr>
@@ -7419,7 +7359,7 @@
       </p:sp>
       <p:sp>
         <p:nvSpPr>
-          <p:cNvPr id="255" name="TextBox 2"/>
+          <p:cNvPr id="254" name="TextBox 2"/>
           <p:cNvSpPr/>
           <p:nvPr/>
         </p:nvSpPr>
@@ -7470,7 +7410,7 @@
       </p:sp>
       <p:sp>
         <p:nvSpPr>
-          <p:cNvPr id="256" name="TextBox 3"/>
+          <p:cNvPr id="255" name="TextBox 3"/>
           <p:cNvSpPr/>
           <p:nvPr/>
         </p:nvSpPr>
@@ -7521,7 +7461,7 @@
       </p:sp>
       <p:sp>
         <p:nvSpPr>
-          <p:cNvPr id="257" name="TextBox 4"/>
+          <p:cNvPr id="256" name="TextBox 4"/>
           <p:cNvSpPr/>
           <p:nvPr/>
         </p:nvSpPr>
@@ -7572,7 +7512,7 @@
       </p:sp>
       <p:sp>
         <p:nvSpPr>
-          <p:cNvPr id="258" name="Rectangle 5"/>
+          <p:cNvPr id="257" name="Rectangle 5"/>
           <p:cNvSpPr/>
           <p:nvPr/>
         </p:nvSpPr>
@@ -7616,7 +7556,7 @@
       </p:sp>
       <p:sp>
         <p:nvSpPr>
-          <p:cNvPr id="259" name="TextBox 6"/>
+          <p:cNvPr id="258" name="TextBox 6"/>
           <p:cNvSpPr/>
           <p:nvPr/>
         </p:nvSpPr>
@@ -7667,7 +7607,7 @@
       </p:sp>
       <p:sp>
         <p:nvSpPr>
-          <p:cNvPr id="260" name="TextBox 7"/>
+          <p:cNvPr id="259" name="TextBox 7"/>
           <p:cNvSpPr/>
           <p:nvPr/>
         </p:nvSpPr>
@@ -7746,7 +7686,7 @@
       </p:sp>
       <p:sp>
         <p:nvSpPr>
-          <p:cNvPr id="261" name="Rectangle 8"/>
+          <p:cNvPr id="260" name="Rectangle 8"/>
           <p:cNvSpPr/>
           <p:nvPr/>
         </p:nvSpPr>
@@ -7790,7 +7730,7 @@
       </p:sp>
       <p:sp>
         <p:nvSpPr>
-          <p:cNvPr id="262" name="TextBox 9"/>
+          <p:cNvPr id="261" name="TextBox 9"/>
           <p:cNvSpPr/>
           <p:nvPr/>
         </p:nvSpPr>
@@ -7841,7 +7781,7 @@
       </p:sp>
       <p:sp>
         <p:nvSpPr>
-          <p:cNvPr id="263" name="TextBox 10"/>
+          <p:cNvPr id="262" name="TextBox 10"/>
           <p:cNvSpPr/>
           <p:nvPr/>
         </p:nvSpPr>
@@ -7892,7 +7832,7 @@
       </p:sp>
       <p:sp>
         <p:nvSpPr>
-          <p:cNvPr id="264" name="TextBox 11"/>
+          <p:cNvPr id="263" name="TextBox 11"/>
           <p:cNvSpPr/>
           <p:nvPr/>
         </p:nvSpPr>
@@ -7999,7 +7939,7 @@
       </p:sp>
       <p:sp>
         <p:nvSpPr>
-          <p:cNvPr id="265" name="Rectangle 12"/>
+          <p:cNvPr id="264" name="Rectangle 12"/>
           <p:cNvSpPr/>
           <p:nvPr/>
         </p:nvSpPr>
@@ -8043,7 +7983,7 @@
       </p:sp>
       <p:sp>
         <p:nvSpPr>
-          <p:cNvPr id="266" name="TextBox 13"/>
+          <p:cNvPr id="265" name="TextBox 13"/>
           <p:cNvSpPr/>
           <p:nvPr/>
         </p:nvSpPr>
@@ -8124,7 +8064,7 @@
       </p:grpSpPr>
       <p:sp>
         <p:nvSpPr>
-          <p:cNvPr id="267" name="Rectangle 1"/>
+          <p:cNvPr id="266" name="Rectangle 1"/>
           <p:cNvSpPr/>
           <p:nvPr/>
         </p:nvSpPr>
@@ -8165,7 +8105,7 @@
       </p:sp>
       <p:sp>
         <p:nvSpPr>
-          <p:cNvPr id="268" name="TextBox 2"/>
+          <p:cNvPr id="267" name="TextBox 2"/>
           <p:cNvSpPr/>
           <p:nvPr/>
         </p:nvSpPr>
@@ -8216,7 +8156,7 @@
       </p:sp>
       <p:sp>
         <p:nvSpPr>
-          <p:cNvPr id="269" name="TextBox 3"/>
+          <p:cNvPr id="268" name="TextBox 3"/>
           <p:cNvSpPr/>
           <p:nvPr/>
         </p:nvSpPr>
@@ -8267,7 +8207,7 @@
       </p:sp>
       <p:sp>
         <p:nvSpPr>
-          <p:cNvPr id="270" name="TextBox 4"/>
+          <p:cNvPr id="269" name="TextBox 4"/>
           <p:cNvSpPr/>
           <p:nvPr/>
         </p:nvSpPr>
@@ -8318,7 +8258,7 @@
       </p:sp>
       <p:sp>
         <p:nvSpPr>
-          <p:cNvPr id="271" name="Rectangle 5"/>
+          <p:cNvPr id="270" name="Rectangle 5"/>
           <p:cNvSpPr/>
           <p:nvPr/>
         </p:nvSpPr>
@@ -8362,7 +8302,7 @@
       </p:sp>
       <p:sp>
         <p:nvSpPr>
-          <p:cNvPr id="272" name="TextBox 6"/>
+          <p:cNvPr id="271" name="TextBox 6"/>
           <p:cNvSpPr/>
           <p:nvPr/>
         </p:nvSpPr>
@@ -8413,7 +8353,7 @@
       </p:sp>
       <p:sp>
         <p:nvSpPr>
-          <p:cNvPr id="273" name="TextBox 7"/>
+          <p:cNvPr id="272" name="TextBox 7"/>
           <p:cNvSpPr/>
           <p:nvPr/>
         </p:nvSpPr>
@@ -8565,7 +8505,7 @@
       </p:sp>
       <p:sp>
         <p:nvSpPr>
-          <p:cNvPr id="274" name="Rectangle 8"/>
+          <p:cNvPr id="273" name="Rectangle 8"/>
           <p:cNvSpPr/>
           <p:nvPr/>
         </p:nvSpPr>
@@ -8609,7 +8549,7 @@
       </p:sp>
       <p:sp>
         <p:nvSpPr>
-          <p:cNvPr id="275" name="TextBox 9"/>
+          <p:cNvPr id="274" name="TextBox 9"/>
           <p:cNvSpPr/>
           <p:nvPr/>
         </p:nvSpPr>
@@ -8660,7 +8600,7 @@
       </p:sp>
       <p:sp>
         <p:nvSpPr>
-          <p:cNvPr id="276" name="TextBox 10"/>
+          <p:cNvPr id="275" name="TextBox 10"/>
           <p:cNvSpPr/>
           <p:nvPr/>
         </p:nvSpPr>
@@ -8812,7 +8752,7 @@
       </p:sp>
       <p:sp>
         <p:nvSpPr>
-          <p:cNvPr id="277" name="Rectangle 11"/>
+          <p:cNvPr id="276" name="Rectangle 11"/>
           <p:cNvSpPr/>
           <p:nvPr/>
         </p:nvSpPr>
@@ -8856,7 +8796,7 @@
       </p:sp>
       <p:sp>
         <p:nvSpPr>
-          <p:cNvPr id="278" name="TextBox 12"/>
+          <p:cNvPr id="277" name="TextBox 12"/>
           <p:cNvSpPr/>
           <p:nvPr/>
         </p:nvSpPr>
@@ -8907,7 +8847,7 @@
       </p:sp>
       <p:sp>
         <p:nvSpPr>
-          <p:cNvPr id="279" name="TextBox 13"/>
+          <p:cNvPr id="278" name="TextBox 13"/>
           <p:cNvSpPr/>
           <p:nvPr/>
         </p:nvSpPr>
@@ -9089,7 +9029,7 @@
       </p:grpSpPr>
       <p:sp>
         <p:nvSpPr>
-          <p:cNvPr id="280" name="Rectangle 1"/>
+          <p:cNvPr id="279" name="Rectangle 1"/>
           <p:cNvSpPr/>
           <p:nvPr/>
         </p:nvSpPr>
@@ -9130,7 +9070,7 @@
       </p:sp>
       <p:sp>
         <p:nvSpPr>
-          <p:cNvPr id="281" name="TextBox 2"/>
+          <p:cNvPr id="280" name="TextBox 2"/>
           <p:cNvSpPr/>
           <p:nvPr/>
         </p:nvSpPr>
@@ -9181,7 +9121,7 @@
       </p:sp>
       <p:sp>
         <p:nvSpPr>
-          <p:cNvPr id="282" name="TextBox 3"/>
+          <p:cNvPr id="281" name="TextBox 3"/>
           <p:cNvSpPr/>
           <p:nvPr/>
         </p:nvSpPr>
@@ -9232,7 +9172,7 @@
       </p:sp>
       <p:sp>
         <p:nvSpPr>
-          <p:cNvPr id="283" name="TextBox 4"/>
+          <p:cNvPr id="282" name="TextBox 4"/>
           <p:cNvSpPr/>
           <p:nvPr/>
         </p:nvSpPr>
@@ -9283,7 +9223,7 @@
       </p:sp>
       <p:sp>
         <p:nvSpPr>
-          <p:cNvPr id="284" name="Rectangle 5"/>
+          <p:cNvPr id="283" name="Rectangle 5"/>
           <p:cNvSpPr/>
           <p:nvPr/>
         </p:nvSpPr>
@@ -9324,7 +9264,7 @@
       </p:sp>
       <p:sp>
         <p:nvSpPr>
-          <p:cNvPr id="285" name="TextBox 6"/>
+          <p:cNvPr id="284" name="TextBox 6"/>
           <p:cNvSpPr/>
           <p:nvPr/>
         </p:nvSpPr>
@@ -9375,7 +9315,7 @@
       </p:sp>
       <p:sp>
         <p:nvSpPr>
-          <p:cNvPr id="286" name="Rectangle 7"/>
+          <p:cNvPr id="285" name="Rectangle 7"/>
           <p:cNvSpPr/>
           <p:nvPr/>
         </p:nvSpPr>
@@ -9419,7 +9359,7 @@
       </p:sp>
       <p:sp>
         <p:nvSpPr>
-          <p:cNvPr id="287" name="TextBox 8"/>
+          <p:cNvPr id="286" name="TextBox 8"/>
           <p:cNvSpPr/>
           <p:nvPr/>
         </p:nvSpPr>
@@ -9470,7 +9410,7 @@
       </p:sp>
       <p:sp>
         <p:nvSpPr>
-          <p:cNvPr id="288" name="TextBox 9"/>
+          <p:cNvPr id="287" name="TextBox 9"/>
           <p:cNvSpPr/>
           <p:nvPr/>
         </p:nvSpPr>
@@ -9535,7 +9475,7 @@
       </p:sp>
       <p:sp>
         <p:nvSpPr>
-          <p:cNvPr id="289" name="Rectangle 10"/>
+          <p:cNvPr id="288" name="Rectangle 10"/>
           <p:cNvSpPr/>
           <p:nvPr/>
         </p:nvSpPr>
@@ -9579,7 +9519,7 @@
       </p:sp>
       <p:sp>
         <p:nvSpPr>
-          <p:cNvPr id="290" name="TextBox 11"/>
+          <p:cNvPr id="289" name="TextBox 11"/>
           <p:cNvSpPr/>
           <p:nvPr/>
         </p:nvSpPr>
@@ -9630,7 +9570,7 @@
       </p:sp>
       <p:sp>
         <p:nvSpPr>
-          <p:cNvPr id="291" name="TextBox 12"/>
+          <p:cNvPr id="290" name="TextBox 12"/>
           <p:cNvSpPr/>
           <p:nvPr/>
         </p:nvSpPr>
@@ -9695,7 +9635,7 @@
       </p:sp>
       <p:sp>
         <p:nvSpPr>
-          <p:cNvPr id="292" name="Rectangle 13"/>
+          <p:cNvPr id="291" name="Rectangle 13"/>
           <p:cNvSpPr/>
           <p:nvPr/>
         </p:nvSpPr>
@@ -9739,7 +9679,7 @@
       </p:sp>
       <p:sp>
         <p:nvSpPr>
-          <p:cNvPr id="293" name="TextBox 14"/>
+          <p:cNvPr id="292" name="TextBox 14"/>
           <p:cNvSpPr/>
           <p:nvPr/>
         </p:nvSpPr>
@@ -9790,7 +9730,7 @@
       </p:sp>
       <p:sp>
         <p:nvSpPr>
-          <p:cNvPr id="294" name="TextBox 15"/>
+          <p:cNvPr id="293" name="TextBox 15"/>
           <p:cNvSpPr/>
           <p:nvPr/>
         </p:nvSpPr>
@@ -9855,7 +9795,7 @@
       </p:sp>
       <p:sp>
         <p:nvSpPr>
-          <p:cNvPr id="295" name="Rectangle 16"/>
+          <p:cNvPr id="294" name="Rectangle 16"/>
           <p:cNvSpPr/>
           <p:nvPr/>
         </p:nvSpPr>
@@ -9899,7 +9839,7 @@
       </p:sp>
       <p:sp>
         <p:nvSpPr>
-          <p:cNvPr id="296" name="TextBox 17"/>
+          <p:cNvPr id="295" name="TextBox 17"/>
           <p:cNvSpPr/>
           <p:nvPr/>
         </p:nvSpPr>
@@ -9950,7 +9890,7 @@
       </p:sp>
       <p:sp>
         <p:nvSpPr>
-          <p:cNvPr id="297" name="TextBox 18"/>
+          <p:cNvPr id="296" name="TextBox 18"/>
           <p:cNvSpPr/>
           <p:nvPr/>
         </p:nvSpPr>
@@ -10015,7 +9955,7 @@
       </p:sp>
       <p:sp>
         <p:nvSpPr>
-          <p:cNvPr id="298" name="Rectangle 19"/>
+          <p:cNvPr id="297" name="Rectangle 19"/>
           <p:cNvSpPr/>
           <p:nvPr/>
         </p:nvSpPr>
@@ -10059,7 +9999,7 @@
       </p:sp>
       <p:sp>
         <p:nvSpPr>
-          <p:cNvPr id="299" name="TextBox 20"/>
+          <p:cNvPr id="298" name="TextBox 20"/>
           <p:cNvSpPr/>
           <p:nvPr/>
         </p:nvSpPr>
@@ -10110,7 +10050,7 @@
       </p:sp>
       <p:sp>
         <p:nvSpPr>
-          <p:cNvPr id="300" name="TextBox 21"/>
+          <p:cNvPr id="299" name="TextBox 21"/>
           <p:cNvSpPr/>
           <p:nvPr/>
         </p:nvSpPr>
@@ -10175,7 +10115,7 @@
       </p:sp>
       <p:sp>
         <p:nvSpPr>
-          <p:cNvPr id="301" name="Rectangle 22"/>
+          <p:cNvPr id="300" name="Rectangle 22"/>
           <p:cNvSpPr/>
           <p:nvPr/>
         </p:nvSpPr>
@@ -10219,7 +10159,7 @@
       </p:sp>
       <p:sp>
         <p:nvSpPr>
-          <p:cNvPr id="302" name="TextBox 23"/>
+          <p:cNvPr id="301" name="TextBox 23"/>
           <p:cNvSpPr/>
           <p:nvPr/>
         </p:nvSpPr>
@@ -10270,7 +10210,7 @@
       </p:sp>
       <p:sp>
         <p:nvSpPr>
-          <p:cNvPr id="303" name="TextBox 24"/>
+          <p:cNvPr id="302" name="TextBox 24"/>
           <p:cNvSpPr/>
           <p:nvPr/>
         </p:nvSpPr>
@@ -10335,7 +10275,7 @@
       </p:sp>
       <p:sp>
         <p:nvSpPr>
-          <p:cNvPr id="304" name="Rectangle 25"/>
+          <p:cNvPr id="303" name="Rectangle 25"/>
           <p:cNvSpPr/>
           <p:nvPr/>
         </p:nvSpPr>
@@ -10376,7 +10316,7 @@
       </p:sp>
       <p:sp>
         <p:nvSpPr>
-          <p:cNvPr id="305" name="TextBox 26"/>
+          <p:cNvPr id="304" name="TextBox 26"/>
           <p:cNvSpPr/>
           <p:nvPr/>
         </p:nvSpPr>
@@ -10427,7 +10367,7 @@
       </p:sp>
       <p:sp>
         <p:nvSpPr>
-          <p:cNvPr id="306" name="TextBox 27"/>
+          <p:cNvPr id="305" name="TextBox 27"/>
           <p:cNvSpPr/>
           <p:nvPr/>
         </p:nvSpPr>
@@ -10478,7 +10418,7 @@
       </p:sp>
       <p:sp>
         <p:nvSpPr>
-          <p:cNvPr id="307" name="TextBox 28"/>
+          <p:cNvPr id="306" name="TextBox 28"/>
           <p:cNvSpPr/>
           <p:nvPr/>
         </p:nvSpPr>
@@ -10529,7 +10469,7 @@
       </p:sp>
       <p:sp>
         <p:nvSpPr>
-          <p:cNvPr id="308" name="TextBox 29"/>
+          <p:cNvPr id="307" name="TextBox 29"/>
           <p:cNvSpPr/>
           <p:nvPr/>
         </p:nvSpPr>
@@ -10580,7 +10520,7 @@
       </p:sp>
       <p:sp>
         <p:nvSpPr>
-          <p:cNvPr id="309" name="TextBox 30"/>
+          <p:cNvPr id="308" name="TextBox 30"/>
           <p:cNvSpPr/>
           <p:nvPr/>
         </p:nvSpPr>
@@ -10631,7 +10571,7 @@
       </p:sp>
       <p:sp>
         <p:nvSpPr>
-          <p:cNvPr id="310" name="Rectangle 31"/>
+          <p:cNvPr id="309" name="Rectangle 31"/>
           <p:cNvSpPr/>
           <p:nvPr/>
         </p:nvSpPr>
@@ -10675,7 +10615,7 @@
       </p:sp>
       <p:sp>
         <p:nvSpPr>
-          <p:cNvPr id="311" name="TextBox 32"/>
+          <p:cNvPr id="310" name="TextBox 32"/>
           <p:cNvSpPr/>
           <p:nvPr/>
         </p:nvSpPr>
@@ -10726,7 +10666,7 @@
       </p:sp>
       <p:sp>
         <p:nvSpPr>
-          <p:cNvPr id="312" name="TextBox 33"/>
+          <p:cNvPr id="311" name="TextBox 33"/>
           <p:cNvSpPr/>
           <p:nvPr/>
         </p:nvSpPr>
@@ -10777,7 +10717,7 @@
       </p:sp>
       <p:sp>
         <p:nvSpPr>
-          <p:cNvPr id="313" name="TextBox 34"/>
+          <p:cNvPr id="312" name="TextBox 34"/>
           <p:cNvSpPr/>
           <p:nvPr/>
         </p:nvSpPr>
@@ -10828,7 +10768,7 @@
       </p:sp>
       <p:sp>
         <p:nvSpPr>
-          <p:cNvPr id="314" name="TextBox 35"/>
+          <p:cNvPr id="313" name="TextBox 35"/>
           <p:cNvSpPr/>
           <p:nvPr/>
         </p:nvSpPr>
@@ -10879,7 +10819,7 @@
       </p:sp>
       <p:sp>
         <p:nvSpPr>
-          <p:cNvPr id="315" name="Rectangle 36"/>
+          <p:cNvPr id="314" name="Rectangle 36"/>
           <p:cNvSpPr/>
           <p:nvPr/>
         </p:nvSpPr>
@@ -10923,7 +10863,7 @@
       </p:sp>
       <p:sp>
         <p:nvSpPr>
-          <p:cNvPr id="316" name="TextBox 37"/>
+          <p:cNvPr id="315" name="TextBox 37"/>
           <p:cNvSpPr/>
           <p:nvPr/>
         </p:nvSpPr>
@@ -10974,7 +10914,7 @@
       </p:sp>
       <p:sp>
         <p:nvSpPr>
-          <p:cNvPr id="317" name="TextBox 38"/>
+          <p:cNvPr id="316" name="TextBox 38"/>
           <p:cNvSpPr/>
           <p:nvPr/>
         </p:nvSpPr>
@@ -11025,7 +10965,7 @@
       </p:sp>
       <p:sp>
         <p:nvSpPr>
-          <p:cNvPr id="318" name="TextBox 39"/>
+          <p:cNvPr id="317" name="TextBox 39"/>
           <p:cNvSpPr/>
           <p:nvPr/>
         </p:nvSpPr>
@@ -11076,7 +11016,7 @@
       </p:sp>
       <p:sp>
         <p:nvSpPr>
-          <p:cNvPr id="319" name="TextBox 40"/>
+          <p:cNvPr id="318" name="TextBox 40"/>
           <p:cNvSpPr/>
           <p:nvPr/>
         </p:nvSpPr>
@@ -11127,7 +11067,7 @@
       </p:sp>
       <p:sp>
         <p:nvSpPr>
-          <p:cNvPr id="320" name="Rectangle 41"/>
+          <p:cNvPr id="319" name="Rectangle 41"/>
           <p:cNvSpPr/>
           <p:nvPr/>
         </p:nvSpPr>
@@ -11171,7 +11111,7 @@
       </p:sp>
       <p:sp>
         <p:nvSpPr>
-          <p:cNvPr id="321" name="TextBox 42"/>
+          <p:cNvPr id="320" name="TextBox 42"/>
           <p:cNvSpPr/>
           <p:nvPr/>
         </p:nvSpPr>
@@ -11222,7 +11162,7 @@
       </p:sp>
       <p:sp>
         <p:nvSpPr>
-          <p:cNvPr id="322" name="TextBox 43"/>
+          <p:cNvPr id="321" name="TextBox 43"/>
           <p:cNvSpPr/>
           <p:nvPr/>
         </p:nvSpPr>
@@ -11273,7 +11213,7 @@
       </p:sp>
       <p:sp>
         <p:nvSpPr>
-          <p:cNvPr id="323" name="TextBox 44"/>
+          <p:cNvPr id="322" name="TextBox 44"/>
           <p:cNvSpPr/>
           <p:nvPr/>
         </p:nvSpPr>
@@ -11324,7 +11264,7 @@
       </p:sp>
       <p:sp>
         <p:nvSpPr>
-          <p:cNvPr id="324" name="TextBox 45"/>
+          <p:cNvPr id="323" name="TextBox 45"/>
           <p:cNvSpPr/>
           <p:nvPr/>
         </p:nvSpPr>
@@ -11375,7 +11315,7 @@
       </p:sp>
       <p:sp>
         <p:nvSpPr>
-          <p:cNvPr id="325" name="Rectangle 46"/>
+          <p:cNvPr id="324" name="Rectangle 46"/>
           <p:cNvSpPr/>
           <p:nvPr/>
         </p:nvSpPr>
@@ -11416,7 +11356,7 @@
       </p:sp>
       <p:sp>
         <p:nvSpPr>
-          <p:cNvPr id="326" name="TextBox 47"/>
+          <p:cNvPr id="325" name="TextBox 47"/>
           <p:cNvSpPr/>
           <p:nvPr/>
         </p:nvSpPr>
@@ -11467,7 +11407,7 @@
       </p:sp>
       <p:sp>
         <p:nvSpPr>
-          <p:cNvPr id="327" name="Rectangle 48"/>
+          <p:cNvPr id="326" name="Rectangle 48"/>
           <p:cNvSpPr/>
           <p:nvPr/>
         </p:nvSpPr>
@@ -11511,7 +11451,7 @@
       </p:sp>
       <p:sp>
         <p:nvSpPr>
-          <p:cNvPr id="328" name="TextBox 49"/>
+          <p:cNvPr id="327" name="TextBox 49"/>
           <p:cNvSpPr/>
           <p:nvPr/>
         </p:nvSpPr>
@@ -11562,7 +11502,7 @@
       </p:sp>
       <p:sp>
         <p:nvSpPr>
-          <p:cNvPr id="329" name="TextBox 50"/>
+          <p:cNvPr id="328" name="TextBox 50"/>
           <p:cNvSpPr/>
           <p:nvPr/>
         </p:nvSpPr>
@@ -11613,7 +11553,7 @@
       </p:sp>
       <p:sp>
         <p:nvSpPr>
-          <p:cNvPr id="330" name="Rectangle 51"/>
+          <p:cNvPr id="329" name="Rectangle 51"/>
           <p:cNvSpPr/>
           <p:nvPr/>
         </p:nvSpPr>
@@ -11657,7 +11597,7 @@
       </p:sp>
       <p:sp>
         <p:nvSpPr>
-          <p:cNvPr id="331" name="TextBox 52"/>
+          <p:cNvPr id="330" name="TextBox 52"/>
           <p:cNvSpPr/>
           <p:nvPr/>
         </p:nvSpPr>
@@ -11708,7 +11648,7 @@
       </p:sp>
       <p:sp>
         <p:nvSpPr>
-          <p:cNvPr id="332" name="TextBox 53"/>
+          <p:cNvPr id="331" name="TextBox 53"/>
           <p:cNvSpPr/>
           <p:nvPr/>
         </p:nvSpPr>
@@ -11759,7 +11699,7 @@
       </p:sp>
       <p:sp>
         <p:nvSpPr>
-          <p:cNvPr id="333" name="Rectangle 54"/>
+          <p:cNvPr id="332" name="Rectangle 54"/>
           <p:cNvSpPr/>
           <p:nvPr/>
         </p:nvSpPr>
@@ -11803,7 +11743,7 @@
       </p:sp>
       <p:sp>
         <p:nvSpPr>
-          <p:cNvPr id="334" name="TextBox 55"/>
+          <p:cNvPr id="333" name="TextBox 55"/>
           <p:cNvSpPr/>
           <p:nvPr/>
         </p:nvSpPr>
@@ -11854,7 +11794,7 @@
       </p:sp>
       <p:sp>
         <p:nvSpPr>
-          <p:cNvPr id="335" name="TextBox 56"/>
+          <p:cNvPr id="334" name="TextBox 56"/>
           <p:cNvSpPr/>
           <p:nvPr/>
         </p:nvSpPr>
@@ -11905,7 +11845,7 @@
       </p:sp>
       <p:sp>
         <p:nvSpPr>
-          <p:cNvPr id="336" name="Rectangle 57"/>
+          <p:cNvPr id="335" name="Rectangle 57"/>
           <p:cNvSpPr/>
           <p:nvPr/>
         </p:nvSpPr>
@@ -11949,7 +11889,7 @@
       </p:sp>
       <p:sp>
         <p:nvSpPr>
-          <p:cNvPr id="337" name="TextBox 58"/>
+          <p:cNvPr id="336" name="TextBox 58"/>
           <p:cNvSpPr/>
           <p:nvPr/>
         </p:nvSpPr>
@@ -12000,7 +11940,7 @@
       </p:sp>
       <p:sp>
         <p:nvSpPr>
-          <p:cNvPr id="338" name="TextBox 59"/>
+          <p:cNvPr id="337" name="TextBox 59"/>
           <p:cNvSpPr/>
           <p:nvPr/>
         </p:nvSpPr>
@@ -12051,7 +11991,7 @@
       </p:sp>
       <p:sp>
         <p:nvSpPr>
-          <p:cNvPr id="339" name="Rectangle 60"/>
+          <p:cNvPr id="338" name="Rectangle 60"/>
           <p:cNvSpPr/>
           <p:nvPr/>
         </p:nvSpPr>
@@ -12095,7 +12035,7 @@
       </p:sp>
       <p:sp>
         <p:nvSpPr>
-          <p:cNvPr id="340" name="TextBox 61"/>
+          <p:cNvPr id="339" name="TextBox 61"/>
           <p:cNvSpPr/>
           <p:nvPr/>
         </p:nvSpPr>
@@ -12146,7 +12086,7 @@
       </p:sp>
       <p:sp>
         <p:nvSpPr>
-          <p:cNvPr id="341" name="TextBox 62"/>
+          <p:cNvPr id="340" name="TextBox 62"/>
           <p:cNvSpPr/>
           <p:nvPr/>
         </p:nvSpPr>
@@ -12197,7 +12137,7 @@
       </p:sp>
       <p:sp>
         <p:nvSpPr>
-          <p:cNvPr id="342" name="TextBox 63"/>
+          <p:cNvPr id="341" name="TextBox 63"/>
           <p:cNvSpPr/>
           <p:nvPr/>
         </p:nvSpPr>
@@ -12278,7 +12218,7 @@
       </p:grpSpPr>
       <p:sp>
         <p:nvSpPr>
-          <p:cNvPr id="343" name="Rectangle 1"/>
+          <p:cNvPr id="342" name="Rectangle 1"/>
           <p:cNvSpPr/>
           <p:nvPr/>
         </p:nvSpPr>
@@ -12319,7 +12259,7 @@
       </p:sp>
       <p:sp>
         <p:nvSpPr>
-          <p:cNvPr id="344" name="TextBox 2"/>
+          <p:cNvPr id="343" name="TextBox 2"/>
           <p:cNvSpPr/>
           <p:nvPr/>
         </p:nvSpPr>
@@ -12370,7 +12310,7 @@
       </p:sp>
       <p:sp>
         <p:nvSpPr>
-          <p:cNvPr id="345" name="TextBox 3"/>
+          <p:cNvPr id="344" name="TextBox 3"/>
           <p:cNvSpPr/>
           <p:nvPr/>
         </p:nvSpPr>
@@ -12421,7 +12361,7 @@
       </p:sp>
       <p:sp>
         <p:nvSpPr>
-          <p:cNvPr id="346" name="Rectangle 4"/>
+          <p:cNvPr id="345" name="Rectangle 4"/>
           <p:cNvSpPr/>
           <p:nvPr/>
         </p:nvSpPr>
@@ -12465,7 +12405,7 @@
       </p:sp>
       <p:sp>
         <p:nvSpPr>
-          <p:cNvPr id="347" name="TextBox 5"/>
+          <p:cNvPr id="346" name="TextBox 5"/>
           <p:cNvSpPr/>
           <p:nvPr/>
         </p:nvSpPr>
@@ -12516,7 +12456,7 @@
       </p:sp>
       <p:sp>
         <p:nvSpPr>
-          <p:cNvPr id="348" name="TextBox 6"/>
+          <p:cNvPr id="347" name="TextBox 6"/>
           <p:cNvSpPr/>
           <p:nvPr/>
         </p:nvSpPr>
@@ -12691,7 +12631,7 @@
       </p:sp>
       <p:sp>
         <p:nvSpPr>
-          <p:cNvPr id="349" name="Rectangle 7"/>
+          <p:cNvPr id="348" name="Rectangle 7"/>
           <p:cNvSpPr/>
           <p:nvPr/>
         </p:nvSpPr>
@@ -12735,7 +12675,7 @@
       </p:sp>
       <p:sp>
         <p:nvSpPr>
-          <p:cNvPr id="350" name="TextBox 8"/>
+          <p:cNvPr id="349" name="TextBox 8"/>
           <p:cNvSpPr/>
           <p:nvPr/>
         </p:nvSpPr>
@@ -12786,7 +12726,7 @@
       </p:sp>
       <p:sp>
         <p:nvSpPr>
-          <p:cNvPr id="351" name="TextBox 9"/>
+          <p:cNvPr id="350" name="TextBox 9"/>
           <p:cNvSpPr/>
           <p:nvPr/>
         </p:nvSpPr>
@@ -12991,7 +12931,7 @@
       </p:grpSpPr>
       <p:sp>
         <p:nvSpPr>
-          <p:cNvPr id="352" name="Rectangle 1"/>
+          <p:cNvPr id="351" name="Rectangle 1"/>
           <p:cNvSpPr/>
           <p:nvPr/>
         </p:nvSpPr>
@@ -13032,7 +12972,7 @@
       </p:sp>
       <p:sp>
         <p:nvSpPr>
-          <p:cNvPr id="353" name="Rectangle 2"/>
+          <p:cNvPr id="352" name="Rectangle 2"/>
           <p:cNvSpPr/>
           <p:nvPr/>
         </p:nvSpPr>
@@ -13073,7 +13013,7 @@
       </p:sp>
       <p:sp>
         <p:nvSpPr>
-          <p:cNvPr id="354" name="Rectangle 3"/>
+          <p:cNvPr id="353" name="Rectangle 3"/>
           <p:cNvSpPr/>
           <p:nvPr/>
         </p:nvSpPr>
@@ -13114,7 +13054,7 @@
       </p:sp>
       <p:sp>
         <p:nvSpPr>
-          <p:cNvPr id="355" name="TextBox 4"/>
+          <p:cNvPr id="354" name="TextBox 4"/>
           <p:cNvSpPr/>
           <p:nvPr/>
         </p:nvSpPr>
@@ -13165,7 +13105,7 @@
       </p:sp>
       <p:sp>
         <p:nvSpPr>
-          <p:cNvPr id="356" name="TextBox 5"/>
+          <p:cNvPr id="355" name="TextBox 5"/>
           <p:cNvSpPr/>
           <p:nvPr/>
         </p:nvSpPr>
@@ -13216,7 +13156,7 @@
       </p:sp>
       <p:sp>
         <p:nvSpPr>
-          <p:cNvPr id="357" name="TextBox 6"/>
+          <p:cNvPr id="356" name="TextBox 6"/>
           <p:cNvSpPr/>
           <p:nvPr/>
         </p:nvSpPr>
@@ -13267,7 +13207,7 @@
       </p:sp>
       <p:sp>
         <p:nvSpPr>
-          <p:cNvPr id="358" name="Rectangle 7"/>
+          <p:cNvPr id="357" name="Rectangle 7"/>
           <p:cNvSpPr/>
           <p:nvPr/>
         </p:nvSpPr>
@@ -13311,7 +13251,7 @@
       </p:sp>
       <p:sp>
         <p:nvSpPr>
-          <p:cNvPr id="359" name="TextBox 8"/>
+          <p:cNvPr id="358" name="TextBox 8"/>
           <p:cNvSpPr/>
           <p:nvPr/>
         </p:nvSpPr>
@@ -13362,7 +13302,7 @@
       </p:sp>
       <p:sp>
         <p:nvSpPr>
-          <p:cNvPr id="360" name="TextBox 9"/>
+          <p:cNvPr id="359" name="TextBox 9"/>
           <p:cNvSpPr/>
           <p:nvPr/>
         </p:nvSpPr>
@@ -13427,7 +13367,7 @@
       </p:sp>
       <p:sp>
         <p:nvSpPr>
-          <p:cNvPr id="361" name="Rectangle 10"/>
+          <p:cNvPr id="360" name="Rectangle 10"/>
           <p:cNvSpPr/>
           <p:nvPr/>
         </p:nvSpPr>
@@ -13471,7 +13411,7 @@
       </p:sp>
       <p:sp>
         <p:nvSpPr>
-          <p:cNvPr id="362" name="TextBox 11"/>
+          <p:cNvPr id="361" name="TextBox 11"/>
           <p:cNvSpPr/>
           <p:nvPr/>
         </p:nvSpPr>
@@ -13522,7 +13462,7 @@
       </p:sp>
       <p:sp>
         <p:nvSpPr>
-          <p:cNvPr id="363" name="TextBox 12"/>
+          <p:cNvPr id="362" name="TextBox 12"/>
           <p:cNvSpPr/>
           <p:nvPr/>
         </p:nvSpPr>
@@ -13587,7 +13527,7 @@
       </p:sp>
       <p:sp>
         <p:nvSpPr>
-          <p:cNvPr id="364" name="Rectangle 13"/>
+          <p:cNvPr id="363" name="Rectangle 13"/>
           <p:cNvSpPr/>
           <p:nvPr/>
         </p:nvSpPr>
@@ -13631,7 +13571,7 @@
       </p:sp>
       <p:sp>
         <p:nvSpPr>
-          <p:cNvPr id="365" name="TextBox 14"/>
+          <p:cNvPr id="364" name="TextBox 14"/>
           <p:cNvSpPr/>
           <p:nvPr/>
         </p:nvSpPr>
@@ -13682,7 +13622,7 @@
       </p:sp>
       <p:sp>
         <p:nvSpPr>
-          <p:cNvPr id="366" name="TextBox 15"/>
+          <p:cNvPr id="365" name="TextBox 15"/>
           <p:cNvSpPr/>
           <p:nvPr/>
         </p:nvSpPr>
@@ -13747,7 +13687,7 @@
       </p:sp>
       <p:sp>
         <p:nvSpPr>
-          <p:cNvPr id="367" name="Rectangle 16"/>
+          <p:cNvPr id="366" name="Rectangle 16"/>
           <p:cNvSpPr/>
           <p:nvPr/>
         </p:nvSpPr>
@@ -13791,7 +13731,7 @@
       </p:sp>
       <p:sp>
         <p:nvSpPr>
-          <p:cNvPr id="368" name="TextBox 17"/>
+          <p:cNvPr id="367" name="TextBox 17"/>
           <p:cNvSpPr/>
           <p:nvPr/>
         </p:nvSpPr>
@@ -13842,7 +13782,7 @@
       </p:sp>
       <p:sp>
         <p:nvSpPr>
-          <p:cNvPr id="369" name="TextBox 18"/>
+          <p:cNvPr id="368" name="TextBox 18"/>
           <p:cNvSpPr/>
           <p:nvPr/>
         </p:nvSpPr>
@@ -13907,7 +13847,7 @@
       </p:sp>
       <p:sp>
         <p:nvSpPr>
-          <p:cNvPr id="370" name="Rectangle 19"/>
+          <p:cNvPr id="369" name="Rectangle 19"/>
           <p:cNvSpPr/>
           <p:nvPr/>
         </p:nvSpPr>
@@ -13951,7 +13891,7 @@
       </p:sp>
       <p:sp>
         <p:nvSpPr>
-          <p:cNvPr id="371" name="TextBox 20"/>
+          <p:cNvPr id="370" name="TextBox 20"/>
           <p:cNvSpPr/>
           <p:nvPr/>
         </p:nvSpPr>
@@ -14002,7 +13942,7 @@
       </p:sp>
       <p:sp>
         <p:nvSpPr>
-          <p:cNvPr id="372" name="TextBox 21"/>
+          <p:cNvPr id="371" name="TextBox 21"/>
           <p:cNvSpPr/>
           <p:nvPr/>
         </p:nvSpPr>
@@ -14067,7 +14007,7 @@
       </p:sp>
       <p:sp>
         <p:nvSpPr>
-          <p:cNvPr id="373" name="TextBox 22"/>
+          <p:cNvPr id="372" name="TextBox 22"/>
           <p:cNvSpPr/>
           <p:nvPr/>
         </p:nvSpPr>
@@ -16461,57 +16401,6 @@
           </a:p>
         </p:txBody>
       </p:sp>
-      <p:sp>
-        <p:nvSpPr>
-          <p:cNvPr id="91" name="TextBox 14"/>
-          <p:cNvSpPr/>
-          <p:nvPr/>
-        </p:nvSpPr>
-        <p:spPr>
-          <a:xfrm>
-            <a:off x="274320" y="4480560"/>
-            <a:ext cx="11612520" cy="257040"/>
-          </a:xfrm>
-          <a:prstGeom prst="rect">
-            <a:avLst/>
-          </a:prstGeom>
-          <a:noFill/>
-          <a:ln w="0">
-            <a:noFill/>
-          </a:ln>
-        </p:spPr>
-        <p:style>
-          <a:lnRef idx="0"/>
-          <a:fillRef idx="0"/>
-          <a:effectRef idx="0"/>
-          <a:fontRef idx="minor"/>
-        </p:style>
-        <p:txBody>
-          <a:bodyPr lIns="90000" rIns="90000" tIns="45000" bIns="45000" anchor="t">
-            <a:spAutoFit/>
-          </a:bodyPr>
-          <a:p>
-            <a:pPr>
-              <a:lnSpc>
-                <a:spcPct val="100000"/>
-              </a:lnSpc>
-              <a:buNone/>
-            </a:pPr>
-            <a:r>
-              <a:rPr b="0" i="1" lang="en-US" sz="1100" spc="-1" strike="noStrike">
-                <a:solidFill>
-                  <a:srgbClr val="888888"/>
-                </a:solidFill>
-                <a:latin typeface="Calibri"/>
-              </a:rPr>
-              <a:t>BM25Okapi (rank_bm25) index is loaded once at API startup from the same ChromaDB YAML corpus</a:t>
-            </a:r>
-            <a:endParaRPr b="0" lang="en-US" sz="1100" spc="-1" strike="noStrike">
-              <a:latin typeface="Arial"/>
-            </a:endParaRPr>
-          </a:p>
-        </p:txBody>
-      </p:sp>
     </p:spTree>
   </p:cSld>
   <mc:AlternateContent>
@@ -16544,7 +16433,7 @@
       </p:grpSpPr>
       <p:sp>
         <p:nvSpPr>
-          <p:cNvPr id="92" name="Rectangle 1"/>
+          <p:cNvPr id="91" name="Rectangle 1"/>
           <p:cNvSpPr/>
           <p:nvPr/>
         </p:nvSpPr>
@@ -16585,7 +16474,7 @@
       </p:sp>
       <p:sp>
         <p:nvSpPr>
-          <p:cNvPr id="93" name="TextBox 2"/>
+          <p:cNvPr id="92" name="TextBox 2"/>
           <p:cNvSpPr/>
           <p:nvPr/>
         </p:nvSpPr>
@@ -16636,7 +16525,7 @@
       </p:sp>
       <p:sp>
         <p:nvSpPr>
-          <p:cNvPr id="94" name="TextBox 3"/>
+          <p:cNvPr id="93" name="TextBox 3"/>
           <p:cNvSpPr/>
           <p:nvPr/>
         </p:nvSpPr>
@@ -16687,7 +16576,7 @@
       </p:sp>
       <p:sp>
         <p:nvSpPr>
-          <p:cNvPr id="95" name="TextBox 4"/>
+          <p:cNvPr id="94" name="TextBox 4"/>
           <p:cNvSpPr/>
           <p:nvPr/>
         </p:nvSpPr>
@@ -16738,7 +16627,7 @@
       </p:sp>
       <p:sp>
         <p:nvSpPr>
-          <p:cNvPr id="96" name="Rectangle 5"/>
+          <p:cNvPr id="95" name="Rectangle 5"/>
           <p:cNvSpPr/>
           <p:nvPr/>
         </p:nvSpPr>
@@ -16782,7 +16671,7 @@
       </p:sp>
       <p:sp>
         <p:nvSpPr>
-          <p:cNvPr id="97" name="TextBox 6"/>
+          <p:cNvPr id="96" name="TextBox 6"/>
           <p:cNvSpPr/>
           <p:nvPr/>
         </p:nvSpPr>
@@ -16833,7 +16722,7 @@
       </p:sp>
       <p:sp>
         <p:nvSpPr>
-          <p:cNvPr id="98" name="TextBox 7"/>
+          <p:cNvPr id="97" name="TextBox 7"/>
           <p:cNvSpPr/>
           <p:nvPr/>
         </p:nvSpPr>
@@ -16926,7 +16815,7 @@
       </p:sp>
       <p:sp>
         <p:nvSpPr>
-          <p:cNvPr id="99" name="Rectangle 8"/>
+          <p:cNvPr id="98" name="Rectangle 8"/>
           <p:cNvSpPr/>
           <p:nvPr/>
         </p:nvSpPr>
@@ -16970,7 +16859,7 @@
       </p:sp>
       <p:sp>
         <p:nvSpPr>
-          <p:cNvPr id="100" name="TextBox 9"/>
+          <p:cNvPr id="99" name="TextBox 9"/>
           <p:cNvSpPr/>
           <p:nvPr/>
         </p:nvSpPr>
@@ -17021,7 +16910,7 @@
       </p:sp>
       <p:sp>
         <p:nvSpPr>
-          <p:cNvPr id="101" name="TextBox 10"/>
+          <p:cNvPr id="100" name="TextBox 10"/>
           <p:cNvSpPr/>
           <p:nvPr/>
         </p:nvSpPr>
@@ -17173,7 +17062,7 @@
       </p:sp>
       <p:sp>
         <p:nvSpPr>
-          <p:cNvPr id="102" name="Rectangle 11"/>
+          <p:cNvPr id="101" name="Rectangle 11"/>
           <p:cNvSpPr/>
           <p:nvPr/>
         </p:nvSpPr>
@@ -17214,7 +17103,7 @@
       </p:sp>
       <p:sp>
         <p:nvSpPr>
-          <p:cNvPr id="103" name="TextBox 12"/>
+          <p:cNvPr id="102" name="TextBox 12"/>
           <p:cNvSpPr/>
           <p:nvPr/>
         </p:nvSpPr>
@@ -17265,7 +17154,7 @@
       </p:sp>
       <p:sp>
         <p:nvSpPr>
-          <p:cNvPr id="104" name="Rectangle 13"/>
+          <p:cNvPr id="103" name="Rectangle 13"/>
           <p:cNvSpPr/>
           <p:nvPr/>
         </p:nvSpPr>
@@ -17309,7 +17198,7 @@
       </p:sp>
       <p:sp>
         <p:nvSpPr>
-          <p:cNvPr id="105" name="TextBox 14"/>
+          <p:cNvPr id="104" name="TextBox 14"/>
           <p:cNvSpPr/>
           <p:nvPr/>
         </p:nvSpPr>
@@ -17360,7 +17249,7 @@
       </p:sp>
       <p:sp>
         <p:nvSpPr>
-          <p:cNvPr id="106" name="TextBox 15"/>
+          <p:cNvPr id="105" name="TextBox 15"/>
           <p:cNvSpPr/>
           <p:nvPr/>
         </p:nvSpPr>
@@ -17411,7 +17300,7 @@
       </p:sp>
       <p:sp>
         <p:nvSpPr>
-          <p:cNvPr id="107" name="TextBox 16"/>
+          <p:cNvPr id="106" name="TextBox 16"/>
           <p:cNvSpPr/>
           <p:nvPr/>
         </p:nvSpPr>
@@ -17462,7 +17351,7 @@
       </p:sp>
       <p:sp>
         <p:nvSpPr>
-          <p:cNvPr id="108" name="TextBox 17"/>
+          <p:cNvPr id="107" name="TextBox 17"/>
           <p:cNvSpPr/>
           <p:nvPr/>
         </p:nvSpPr>
@@ -17513,7 +17402,7 @@
       </p:sp>
       <p:sp>
         <p:nvSpPr>
-          <p:cNvPr id="109" name="Rectangle 18"/>
+          <p:cNvPr id="108" name="Rectangle 18"/>
           <p:cNvSpPr/>
           <p:nvPr/>
         </p:nvSpPr>
@@ -17557,7 +17446,7 @@
       </p:sp>
       <p:sp>
         <p:nvSpPr>
-          <p:cNvPr id="110" name="TextBox 19"/>
+          <p:cNvPr id="109" name="TextBox 19"/>
           <p:cNvSpPr/>
           <p:nvPr/>
         </p:nvSpPr>
@@ -17608,7 +17497,7 @@
       </p:sp>
       <p:sp>
         <p:nvSpPr>
-          <p:cNvPr id="111" name="TextBox 20"/>
+          <p:cNvPr id="110" name="TextBox 20"/>
           <p:cNvSpPr/>
           <p:nvPr/>
         </p:nvSpPr>
@@ -17659,7 +17548,7 @@
       </p:sp>
       <p:sp>
         <p:nvSpPr>
-          <p:cNvPr id="112" name="TextBox 21"/>
+          <p:cNvPr id="111" name="TextBox 21"/>
           <p:cNvSpPr/>
           <p:nvPr/>
         </p:nvSpPr>
@@ -17710,7 +17599,7 @@
       </p:sp>
       <p:sp>
         <p:nvSpPr>
-          <p:cNvPr id="113" name="TextBox 22"/>
+          <p:cNvPr id="112" name="TextBox 22"/>
           <p:cNvSpPr/>
           <p:nvPr/>
         </p:nvSpPr>
@@ -17761,7 +17650,7 @@
       </p:sp>
       <p:sp>
         <p:nvSpPr>
-          <p:cNvPr id="114" name="Rectangle 23"/>
+          <p:cNvPr id="113" name="Rectangle 23"/>
           <p:cNvSpPr/>
           <p:nvPr/>
         </p:nvSpPr>
@@ -17805,7 +17694,7 @@
       </p:sp>
       <p:sp>
         <p:nvSpPr>
-          <p:cNvPr id="115" name="TextBox 24"/>
+          <p:cNvPr id="114" name="TextBox 24"/>
           <p:cNvSpPr/>
           <p:nvPr/>
         </p:nvSpPr>
@@ -17856,7 +17745,7 @@
       </p:sp>
       <p:sp>
         <p:nvSpPr>
-          <p:cNvPr id="116" name="TextBox 25"/>
+          <p:cNvPr id="115" name="TextBox 25"/>
           <p:cNvSpPr/>
           <p:nvPr/>
         </p:nvSpPr>
@@ -17907,7 +17796,7 @@
       </p:sp>
       <p:sp>
         <p:nvSpPr>
-          <p:cNvPr id="117" name="TextBox 26"/>
+          <p:cNvPr id="116" name="TextBox 26"/>
           <p:cNvSpPr/>
           <p:nvPr/>
         </p:nvSpPr>
@@ -17958,7 +17847,7 @@
       </p:sp>
       <p:sp>
         <p:nvSpPr>
-          <p:cNvPr id="118" name="TextBox 27"/>
+          <p:cNvPr id="117" name="TextBox 27"/>
           <p:cNvSpPr/>
           <p:nvPr/>
         </p:nvSpPr>
@@ -18009,7 +17898,7 @@
       </p:sp>
       <p:sp>
         <p:nvSpPr>
-          <p:cNvPr id="119" name="Rectangle 28"/>
+          <p:cNvPr id="118" name="Rectangle 28"/>
           <p:cNvSpPr/>
           <p:nvPr/>
         </p:nvSpPr>
@@ -18053,7 +17942,7 @@
       </p:sp>
       <p:sp>
         <p:nvSpPr>
-          <p:cNvPr id="120" name="TextBox 29"/>
+          <p:cNvPr id="119" name="TextBox 29"/>
           <p:cNvSpPr/>
           <p:nvPr/>
         </p:nvSpPr>
@@ -18104,7 +17993,7 @@
       </p:sp>
       <p:sp>
         <p:nvSpPr>
-          <p:cNvPr id="121" name="TextBox 30"/>
+          <p:cNvPr id="120" name="TextBox 30"/>
           <p:cNvSpPr/>
           <p:nvPr/>
         </p:nvSpPr>
@@ -18155,7 +18044,7 @@
       </p:sp>
       <p:sp>
         <p:nvSpPr>
-          <p:cNvPr id="122" name="TextBox 31"/>
+          <p:cNvPr id="121" name="TextBox 31"/>
           <p:cNvSpPr/>
           <p:nvPr/>
         </p:nvSpPr>
@@ -18206,7 +18095,7 @@
       </p:sp>
       <p:sp>
         <p:nvSpPr>
-          <p:cNvPr id="123" name="TextBox 32"/>
+          <p:cNvPr id="122" name="TextBox 32"/>
           <p:cNvSpPr/>
           <p:nvPr/>
         </p:nvSpPr>
@@ -18257,7 +18146,7 @@
       </p:sp>
       <p:sp>
         <p:nvSpPr>
-          <p:cNvPr id="124" name="Rectangle 33"/>
+          <p:cNvPr id="123" name="Rectangle 33"/>
           <p:cNvSpPr/>
           <p:nvPr/>
         </p:nvSpPr>
@@ -18301,7 +18190,7 @@
       </p:sp>
       <p:sp>
         <p:nvSpPr>
-          <p:cNvPr id="125" name="TextBox 34"/>
+          <p:cNvPr id="124" name="TextBox 34"/>
           <p:cNvSpPr/>
           <p:nvPr/>
         </p:nvSpPr>
@@ -18352,7 +18241,7 @@
       </p:sp>
       <p:sp>
         <p:nvSpPr>
-          <p:cNvPr id="126" name="TextBox 35"/>
+          <p:cNvPr id="125" name="TextBox 35"/>
           <p:cNvSpPr/>
           <p:nvPr/>
         </p:nvSpPr>
@@ -18403,7 +18292,7 @@
       </p:sp>
       <p:sp>
         <p:nvSpPr>
-          <p:cNvPr id="127" name="TextBox 36"/>
+          <p:cNvPr id="126" name="TextBox 36"/>
           <p:cNvSpPr/>
           <p:nvPr/>
         </p:nvSpPr>
@@ -18454,7 +18343,7 @@
       </p:sp>
       <p:sp>
         <p:nvSpPr>
-          <p:cNvPr id="128" name="TextBox 37"/>
+          <p:cNvPr id="127" name="TextBox 37"/>
           <p:cNvSpPr/>
           <p:nvPr/>
         </p:nvSpPr>
@@ -18505,7 +18394,7 @@
       </p:sp>
       <p:sp>
         <p:nvSpPr>
-          <p:cNvPr id="129" name="Rectangle 38"/>
+          <p:cNvPr id="128" name="Rectangle 38"/>
           <p:cNvSpPr/>
           <p:nvPr/>
         </p:nvSpPr>
@@ -18549,7 +18438,7 @@
       </p:sp>
       <p:sp>
         <p:nvSpPr>
-          <p:cNvPr id="130" name="TextBox 39"/>
+          <p:cNvPr id="129" name="TextBox 39"/>
           <p:cNvSpPr/>
           <p:nvPr/>
         </p:nvSpPr>
@@ -18600,7 +18489,7 @@
       </p:sp>
       <p:sp>
         <p:nvSpPr>
-          <p:cNvPr id="131" name="TextBox 40"/>
+          <p:cNvPr id="130" name="TextBox 40"/>
           <p:cNvSpPr/>
           <p:nvPr/>
         </p:nvSpPr>
@@ -18651,7 +18540,7 @@
       </p:sp>
       <p:sp>
         <p:nvSpPr>
-          <p:cNvPr id="132" name="TextBox 41"/>
+          <p:cNvPr id="131" name="TextBox 41"/>
           <p:cNvSpPr/>
           <p:nvPr/>
         </p:nvSpPr>
@@ -18702,7 +18591,7 @@
       </p:sp>
       <p:sp>
         <p:nvSpPr>
-          <p:cNvPr id="133" name="TextBox 42"/>
+          <p:cNvPr id="132" name="TextBox 42"/>
           <p:cNvSpPr/>
           <p:nvPr/>
         </p:nvSpPr>
@@ -18783,7 +18672,7 @@
       </p:grpSpPr>
       <p:sp>
         <p:nvSpPr>
-          <p:cNvPr id="134" name="Rectangle 1"/>
+          <p:cNvPr id="133" name="Rectangle 1"/>
           <p:cNvSpPr/>
           <p:nvPr/>
         </p:nvSpPr>
@@ -18824,7 +18713,7 @@
       </p:sp>
       <p:sp>
         <p:nvSpPr>
-          <p:cNvPr id="135" name="TextBox 2"/>
+          <p:cNvPr id="134" name="TextBox 2"/>
           <p:cNvSpPr/>
           <p:nvPr/>
         </p:nvSpPr>
@@ -18875,7 +18764,7 @@
       </p:sp>
       <p:sp>
         <p:nvSpPr>
-          <p:cNvPr id="136" name="TextBox 3"/>
+          <p:cNvPr id="135" name="TextBox 3"/>
           <p:cNvSpPr/>
           <p:nvPr/>
         </p:nvSpPr>
@@ -18926,7 +18815,7 @@
       </p:sp>
       <p:sp>
         <p:nvSpPr>
-          <p:cNvPr id="137" name="TextBox 4"/>
+          <p:cNvPr id="136" name="TextBox 4"/>
           <p:cNvSpPr/>
           <p:nvPr/>
         </p:nvSpPr>
@@ -18977,7 +18866,7 @@
       </p:sp>
       <p:pic>
         <p:nvPicPr>
-          <p:cNvPr id="138" name="Picture 5" descr="m6_comparison.png"/>
+          <p:cNvPr id="137" name="Picture 5" descr="m6_comparison.png"/>
           <p:cNvPicPr/>
           <p:nvPr/>
         </p:nvPicPr>
@@ -19000,7 +18889,7 @@
       </p:pic>
       <p:sp>
         <p:nvSpPr>
-          <p:cNvPr id="139" name="Rectangle 6"/>
+          <p:cNvPr id="138" name="Rectangle 6"/>
           <p:cNvSpPr/>
           <p:nvPr/>
         </p:nvSpPr>
@@ -19044,7 +18933,7 @@
       </p:sp>
       <p:sp>
         <p:nvSpPr>
-          <p:cNvPr id="140" name="TextBox 7"/>
+          <p:cNvPr id="139" name="TextBox 7"/>
           <p:cNvSpPr/>
           <p:nvPr/>
         </p:nvSpPr>
@@ -19104,7 +18993,7 @@
       </p:sp>
       <p:sp>
         <p:nvSpPr>
-          <p:cNvPr id="141" name="TextBox 8"/>
+          <p:cNvPr id="140" name="TextBox 8"/>
           <p:cNvSpPr/>
           <p:nvPr/>
         </p:nvSpPr>
@@ -19197,7 +19086,7 @@
       </p:sp>
       <p:sp>
         <p:nvSpPr>
-          <p:cNvPr id="142" name="Rectangle 9"/>
+          <p:cNvPr id="141" name="Rectangle 9"/>
           <p:cNvSpPr/>
           <p:nvPr/>
         </p:nvSpPr>
@@ -19241,7 +19130,7 @@
       </p:sp>
       <p:sp>
         <p:nvSpPr>
-          <p:cNvPr id="143" name="TextBox 10"/>
+          <p:cNvPr id="142" name="TextBox 10"/>
           <p:cNvSpPr/>
           <p:nvPr/>
         </p:nvSpPr>
@@ -19292,7 +19181,7 @@
       </p:sp>
       <p:sp>
         <p:nvSpPr>
-          <p:cNvPr id="144" name="TextBox 11"/>
+          <p:cNvPr id="143" name="TextBox 11"/>
           <p:cNvSpPr/>
           <p:nvPr/>
         </p:nvSpPr>
@@ -19371,7 +19260,7 @@
       </p:sp>
       <p:sp>
         <p:nvSpPr>
-          <p:cNvPr id="145" name="TextBox 12"/>
+          <p:cNvPr id="144" name="TextBox 12"/>
           <p:cNvSpPr/>
           <p:nvPr/>
         </p:nvSpPr>
@@ -19452,7 +19341,7 @@
       </p:grpSpPr>
       <p:sp>
         <p:nvSpPr>
-          <p:cNvPr id="146" name="Rectangle 1"/>
+          <p:cNvPr id="145" name="Rectangle 1"/>
           <p:cNvSpPr/>
           <p:nvPr/>
         </p:nvSpPr>
@@ -19493,7 +19382,7 @@
       </p:sp>
       <p:sp>
         <p:nvSpPr>
-          <p:cNvPr id="147" name="TextBox 2"/>
+          <p:cNvPr id="146" name="TextBox 2"/>
           <p:cNvSpPr/>
           <p:nvPr/>
         </p:nvSpPr>
@@ -19544,7 +19433,7 @@
       </p:sp>
       <p:sp>
         <p:nvSpPr>
-          <p:cNvPr id="148" name="TextBox 3"/>
+          <p:cNvPr id="147" name="TextBox 3"/>
           <p:cNvSpPr/>
           <p:nvPr/>
         </p:nvSpPr>
@@ -19595,7 +19484,7 @@
       </p:sp>
       <p:sp>
         <p:nvSpPr>
-          <p:cNvPr id="149" name="TextBox 4"/>
+          <p:cNvPr id="148" name="TextBox 4"/>
           <p:cNvSpPr/>
           <p:nvPr/>
         </p:nvSpPr>
@@ -19646,7 +19535,7 @@
       </p:sp>
       <p:pic>
         <p:nvPicPr>
-          <p:cNvPr id="150" name="Picture 5" descr="m6_category.png"/>
+          <p:cNvPr id="149" name="Picture 5" descr="m6_category.png"/>
           <p:cNvPicPr/>
           <p:nvPr/>
         </p:nvPicPr>
@@ -19669,7 +19558,7 @@
       </p:pic>
       <p:sp>
         <p:nvSpPr>
-          <p:cNvPr id="151" name="Rectangle 6"/>
+          <p:cNvPr id="150" name="Rectangle 6"/>
           <p:cNvSpPr/>
           <p:nvPr/>
         </p:nvSpPr>
@@ -19713,7 +19602,7 @@
       </p:sp>
       <p:sp>
         <p:nvSpPr>
-          <p:cNvPr id="152" name="TextBox 7"/>
+          <p:cNvPr id="151" name="TextBox 7"/>
           <p:cNvSpPr/>
           <p:nvPr/>
         </p:nvSpPr>
@@ -19764,7 +19653,7 @@
       </p:sp>
       <p:sp>
         <p:nvSpPr>
-          <p:cNvPr id="153" name="TextBox 8"/>
+          <p:cNvPr id="152" name="TextBox 8"/>
           <p:cNvSpPr/>
           <p:nvPr/>
         </p:nvSpPr>
@@ -19815,7 +19704,7 @@
       </p:sp>
       <p:sp>
         <p:nvSpPr>
-          <p:cNvPr id="154" name="TextBox 9"/>
+          <p:cNvPr id="153" name="TextBox 9"/>
           <p:cNvSpPr/>
           <p:nvPr/>
         </p:nvSpPr>
@@ -19866,7 +19755,7 @@
       </p:sp>
       <p:sp>
         <p:nvSpPr>
-          <p:cNvPr id="155" name="TextBox 10"/>
+          <p:cNvPr id="154" name="TextBox 10"/>
           <p:cNvSpPr/>
           <p:nvPr/>
         </p:nvSpPr>
@@ -19917,7 +19806,7 @@
       </p:sp>
       <p:sp>
         <p:nvSpPr>
-          <p:cNvPr id="156" name="TextBox 11"/>
+          <p:cNvPr id="155" name="TextBox 11"/>
           <p:cNvSpPr/>
           <p:nvPr/>
         </p:nvSpPr>
@@ -19968,7 +19857,7 @@
       </p:sp>
       <p:sp>
         <p:nvSpPr>
-          <p:cNvPr id="157" name="TextBox 12"/>
+          <p:cNvPr id="156" name="TextBox 12"/>
           <p:cNvSpPr/>
           <p:nvPr/>
         </p:nvSpPr>
@@ -20019,7 +19908,7 @@
       </p:sp>
       <p:sp>
         <p:nvSpPr>
-          <p:cNvPr id="158" name="TextBox 13"/>
+          <p:cNvPr id="157" name="TextBox 13"/>
           <p:cNvSpPr/>
           <p:nvPr/>
         </p:nvSpPr>
@@ -20070,7 +19959,7 @@
       </p:sp>
       <p:sp>
         <p:nvSpPr>
-          <p:cNvPr id="159" name="TextBox 14"/>
+          <p:cNvPr id="158" name="TextBox 14"/>
           <p:cNvSpPr/>
           <p:nvPr/>
         </p:nvSpPr>
@@ -20121,7 +20010,7 @@
       </p:sp>
       <p:sp>
         <p:nvSpPr>
-          <p:cNvPr id="160" name="TextBox 15"/>
+          <p:cNvPr id="159" name="TextBox 15"/>
           <p:cNvSpPr/>
           <p:nvPr/>
         </p:nvSpPr>
@@ -20202,7 +20091,7 @@
       </p:grpSpPr>
       <p:sp>
         <p:nvSpPr>
-          <p:cNvPr id="161" name="Rectangle 1"/>
+          <p:cNvPr id="160" name="Rectangle 1"/>
           <p:cNvSpPr/>
           <p:nvPr/>
         </p:nvSpPr>
@@ -20243,7 +20132,7 @@
       </p:sp>
       <p:sp>
         <p:nvSpPr>
-          <p:cNvPr id="162" name="TextBox 2"/>
+          <p:cNvPr id="161" name="TextBox 2"/>
           <p:cNvSpPr/>
           <p:nvPr/>
         </p:nvSpPr>
@@ -20294,7 +20183,7 @@
       </p:sp>
       <p:sp>
         <p:nvSpPr>
-          <p:cNvPr id="163" name="TextBox 3"/>
+          <p:cNvPr id="162" name="TextBox 3"/>
           <p:cNvSpPr/>
           <p:nvPr/>
         </p:nvSpPr>
@@ -20345,7 +20234,7 @@
       </p:sp>
       <p:sp>
         <p:nvSpPr>
-          <p:cNvPr id="164" name="TextBox 4"/>
+          <p:cNvPr id="163" name="TextBox 4"/>
           <p:cNvSpPr/>
           <p:nvPr/>
         </p:nvSpPr>
@@ -20396,7 +20285,7 @@
       </p:sp>
       <p:pic>
         <p:nvPicPr>
-          <p:cNvPr id="165" name="Picture 5" descr="m6_latency_v2.png"/>
+          <p:cNvPr id="164" name="Picture 5" descr="m6_latency_v2.png"/>
           <p:cNvPicPr/>
           <p:nvPr/>
         </p:nvPicPr>
@@ -20419,7 +20308,7 @@
       </p:pic>
       <p:sp>
         <p:nvSpPr>
-          <p:cNvPr id="166" name="TextBox 6"/>
+          <p:cNvPr id="165" name="TextBox 6"/>
           <p:cNvSpPr/>
           <p:nvPr/>
         </p:nvSpPr>
@@ -20500,7 +20389,7 @@
       </p:grpSpPr>
       <p:sp>
         <p:nvSpPr>
-          <p:cNvPr id="167" name="Rectangle 1"/>
+          <p:cNvPr id="166" name="Rectangle 1"/>
           <p:cNvSpPr/>
           <p:nvPr/>
         </p:nvSpPr>
@@ -20541,7 +20430,7 @@
       </p:sp>
       <p:sp>
         <p:nvSpPr>
-          <p:cNvPr id="168" name="TextBox 2"/>
+          <p:cNvPr id="167" name="TextBox 2"/>
           <p:cNvSpPr/>
           <p:nvPr/>
         </p:nvSpPr>
@@ -20592,7 +20481,7 @@
       </p:sp>
       <p:sp>
         <p:nvSpPr>
-          <p:cNvPr id="169" name="TextBox 3"/>
+          <p:cNvPr id="168" name="TextBox 3"/>
           <p:cNvSpPr/>
           <p:nvPr/>
         </p:nvSpPr>
@@ -20643,7 +20532,7 @@
       </p:sp>
       <p:sp>
         <p:nvSpPr>
-          <p:cNvPr id="170" name="TextBox 4"/>
+          <p:cNvPr id="169" name="TextBox 4"/>
           <p:cNvSpPr/>
           <p:nvPr/>
         </p:nvSpPr>
@@ -20694,7 +20583,7 @@
       </p:sp>
       <p:sp>
         <p:nvSpPr>
-          <p:cNvPr id="171" name="Rectangle 5"/>
+          <p:cNvPr id="170" name="Rectangle 5"/>
           <p:cNvSpPr/>
           <p:nvPr/>
         </p:nvSpPr>
@@ -20738,7 +20627,7 @@
       </p:sp>
       <p:sp>
         <p:nvSpPr>
-          <p:cNvPr id="172" name="TextBox 6"/>
+          <p:cNvPr id="171" name="TextBox 6"/>
           <p:cNvSpPr/>
           <p:nvPr/>
         </p:nvSpPr>
@@ -20789,7 +20678,7 @@
       </p:sp>
       <p:sp>
         <p:nvSpPr>
-          <p:cNvPr id="173" name="TextBox 7"/>
+          <p:cNvPr id="172" name="TextBox 7"/>
           <p:cNvSpPr/>
           <p:nvPr/>
         </p:nvSpPr>
@@ -20975,7 +20864,7 @@
       </p:sp>
       <p:sp>
         <p:nvSpPr>
-          <p:cNvPr id="174" name="Rectangle 8"/>
+          <p:cNvPr id="173" name="Rectangle 8"/>
           <p:cNvSpPr/>
           <p:nvPr/>
         </p:nvSpPr>
@@ -21019,7 +20908,7 @@
       </p:sp>
       <p:sp>
         <p:nvSpPr>
-          <p:cNvPr id="175" name="TextBox 9"/>
+          <p:cNvPr id="174" name="TextBox 9"/>
           <p:cNvSpPr/>
           <p:nvPr/>
         </p:nvSpPr>
@@ -21070,7 +20959,7 @@
       </p:sp>
       <p:sp>
         <p:nvSpPr>
-          <p:cNvPr id="176" name="TextBox 10"/>
+          <p:cNvPr id="175" name="TextBox 10"/>
           <p:cNvSpPr/>
           <p:nvPr/>
         </p:nvSpPr>
@@ -21283,7 +21172,7 @@
       </p:grpSpPr>
       <p:sp>
         <p:nvSpPr>
-          <p:cNvPr id="177" name="Rectangle 1"/>
+          <p:cNvPr id="176" name="Rectangle 1"/>
           <p:cNvSpPr/>
           <p:nvPr/>
         </p:nvSpPr>
@@ -21324,7 +21213,7 @@
       </p:sp>
       <p:sp>
         <p:nvSpPr>
-          <p:cNvPr id="178" name="TextBox 2"/>
+          <p:cNvPr id="177" name="TextBox 2"/>
           <p:cNvSpPr/>
           <p:nvPr/>
         </p:nvSpPr>
@@ -21375,7 +21264,7 @@
       </p:sp>
       <p:sp>
         <p:nvSpPr>
-          <p:cNvPr id="179" name="TextBox 3"/>
+          <p:cNvPr id="178" name="TextBox 3"/>
           <p:cNvSpPr/>
           <p:nvPr/>
         </p:nvSpPr>
@@ -21426,7 +21315,7 @@
       </p:sp>
       <p:sp>
         <p:nvSpPr>
-          <p:cNvPr id="180" name="TextBox 4"/>
+          <p:cNvPr id="179" name="TextBox 4"/>
           <p:cNvSpPr/>
           <p:nvPr/>
         </p:nvSpPr>
@@ -21477,7 +21366,7 @@
       </p:sp>
       <p:sp>
         <p:nvSpPr>
-          <p:cNvPr id="181" name="Rectangle 5"/>
+          <p:cNvPr id="180" name="Rectangle 5"/>
           <p:cNvSpPr/>
           <p:nvPr/>
         </p:nvSpPr>
@@ -21521,7 +21410,7 @@
       </p:sp>
       <p:sp>
         <p:nvSpPr>
-          <p:cNvPr id="182" name="TextBox 6"/>
+          <p:cNvPr id="181" name="TextBox 6"/>
           <p:cNvSpPr/>
           <p:nvPr/>
         </p:nvSpPr>
@@ -21572,7 +21461,7 @@
       </p:sp>
       <p:sp>
         <p:nvSpPr>
-          <p:cNvPr id="183" name="TextBox 7"/>
+          <p:cNvPr id="182" name="TextBox 7"/>
           <p:cNvSpPr/>
           <p:nvPr/>
         </p:nvSpPr>
@@ -21747,7 +21636,7 @@
       </p:sp>
       <p:sp>
         <p:nvSpPr>
-          <p:cNvPr id="184" name="Rectangle 8"/>
+          <p:cNvPr id="183" name="Rectangle 8"/>
           <p:cNvSpPr/>
           <p:nvPr/>
         </p:nvSpPr>
@@ -21791,7 +21680,7 @@
       </p:sp>
       <p:sp>
         <p:nvSpPr>
-          <p:cNvPr id="185" name="TextBox 9"/>
+          <p:cNvPr id="184" name="TextBox 9"/>
           <p:cNvSpPr/>
           <p:nvPr/>
         </p:nvSpPr>
@@ -21842,7 +21731,7 @@
       </p:sp>
       <p:sp>
         <p:nvSpPr>
-          <p:cNvPr id="186" name="TextBox 10"/>
+          <p:cNvPr id="185" name="TextBox 10"/>
           <p:cNvSpPr/>
           <p:nvPr/>
         </p:nvSpPr>
@@ -22073,7 +21962,7 @@
       </p:sp>
       <p:sp>
         <p:nvSpPr>
-          <p:cNvPr id="187" name="Rectangle 11"/>
+          <p:cNvPr id="186" name="Rectangle 11"/>
           <p:cNvSpPr/>
           <p:nvPr/>
         </p:nvSpPr>
@@ -22114,7 +22003,7 @@
       </p:sp>
       <p:sp>
         <p:nvSpPr>
-          <p:cNvPr id="188" name="TextBox 12"/>
+          <p:cNvPr id="187" name="TextBox 12"/>
           <p:cNvSpPr/>
           <p:nvPr/>
         </p:nvSpPr>
@@ -22165,7 +22054,7 @@
       </p:sp>
       <p:sp>
         <p:nvSpPr>
-          <p:cNvPr id="189" name="TextBox 13"/>
+          <p:cNvPr id="188" name="TextBox 13"/>
           <p:cNvSpPr/>
           <p:nvPr/>
         </p:nvSpPr>
@@ -22323,7 +22212,7 @@
       </p:sp>
       <p:sp>
         <p:nvSpPr>
-          <p:cNvPr id="190" name="Rectangle 14"/>
+          <p:cNvPr id="189" name="Rectangle 14"/>
           <p:cNvSpPr/>
           <p:nvPr/>
         </p:nvSpPr>
@@ -22367,7 +22256,7 @@
       </p:sp>
       <p:sp>
         <p:nvSpPr>
-          <p:cNvPr id="191" name="TextBox 15"/>
+          <p:cNvPr id="190" name="TextBox 15"/>
           <p:cNvSpPr/>
           <p:nvPr/>
         </p:nvSpPr>
@@ -22418,7 +22307,7 @@
       </p:sp>
       <p:sp>
         <p:nvSpPr>
-          <p:cNvPr id="192" name="TextBox 16"/>
+          <p:cNvPr id="191" name="TextBox 16"/>
           <p:cNvSpPr/>
           <p:nvPr/>
         </p:nvSpPr>

</xml_diff>